<commit_message>
Final Commit 8 March
</commit_message>
<xml_diff>
--- a/RISC-V stage 1.pptx
+++ b/RISC-V stage 1.pptx
@@ -4,6 +4,9 @@
   <p:sldMasterIdLst>
     <p:sldMasterId id="2147483648" r:id="rId1"/>
   </p:sldMasterIdLst>
+  <p:notesMasterIdLst>
+    <p:notesMasterId r:id="rId3"/>
+  </p:notesMasterIdLst>
   <p:sldIdLst>
     <p:sldId id="256" r:id="rId2"/>
   </p:sldIdLst>
@@ -112,6 +115,439 @@
 </p:presentation>
 </file>
 
+<file path=ppt/notesMasters/notesMaster1.xml><?xml version="1.0" encoding="utf-8"?>
+<p:notesMaster xmlns:a="http://schemas.openxmlformats.org/drawingml/2006/main" xmlns:r="http://schemas.openxmlformats.org/officeDocument/2006/relationships" xmlns:p="http://schemas.openxmlformats.org/presentationml/2006/main">
+  <p:cSld>
+    <p:bg>
+      <p:bgRef idx="1001">
+        <a:schemeClr val="bg1"/>
+      </p:bgRef>
+    </p:bg>
+    <p:spTree>
+      <p:nvGrpSpPr>
+        <p:cNvPr id="1" name=""/>
+        <p:cNvGrpSpPr/>
+        <p:nvPr/>
+      </p:nvGrpSpPr>
+      <p:grpSpPr>
+        <a:xfrm>
+          <a:off x="0" y="0"/>
+          <a:ext cx="0" cy="0"/>
+          <a:chOff x="0" y="0"/>
+          <a:chExt cx="0" cy="0"/>
+        </a:xfrm>
+      </p:grpSpPr>
+      <p:sp>
+        <p:nvSpPr>
+          <p:cNvPr id="2" name="Header Placeholder 1"/>
+          <p:cNvSpPr>
+            <a:spLocks noGrp="1"/>
+          </p:cNvSpPr>
+          <p:nvPr>
+            <p:ph type="hdr" sz="quarter"/>
+          </p:nvPr>
+        </p:nvSpPr>
+        <p:spPr>
+          <a:xfrm>
+            <a:off x="0" y="0"/>
+            <a:ext cx="3103563" cy="473075"/>
+          </a:xfrm>
+          <a:prstGeom prst="rect">
+            <a:avLst/>
+          </a:prstGeom>
+        </p:spPr>
+        <p:txBody>
+          <a:bodyPr vert="horz" lIns="91440" tIns="45720" rIns="91440" bIns="45720" rtlCol="0"/>
+          <a:lstStyle>
+            <a:lvl1pPr algn="l">
+              <a:defRPr sz="1200"/>
+            </a:lvl1pPr>
+          </a:lstStyle>
+          <a:p>
+            <a:endParaRPr lang="en-US"/>
+          </a:p>
+        </p:txBody>
+      </p:sp>
+      <p:sp>
+        <p:nvSpPr>
+          <p:cNvPr id="3" name="Date Placeholder 2"/>
+          <p:cNvSpPr>
+            <a:spLocks noGrp="1"/>
+          </p:cNvSpPr>
+          <p:nvPr>
+            <p:ph type="dt" idx="1"/>
+          </p:nvPr>
+        </p:nvSpPr>
+        <p:spPr>
+          <a:xfrm>
+            <a:off x="4057650" y="0"/>
+            <a:ext cx="3103563" cy="473075"/>
+          </a:xfrm>
+          <a:prstGeom prst="rect">
+            <a:avLst/>
+          </a:prstGeom>
+        </p:spPr>
+        <p:txBody>
+          <a:bodyPr vert="horz" lIns="91440" tIns="45720" rIns="91440" bIns="45720" rtlCol="0"/>
+          <a:lstStyle>
+            <a:lvl1pPr algn="r">
+              <a:defRPr sz="1200"/>
+            </a:lvl1pPr>
+          </a:lstStyle>
+          <a:p>
+            <a:fld id="{3AAF665D-93E1-4988-A2F8-AD05D120208A}" type="datetimeFigureOut">
+              <a:rPr lang="en-US" smtClean="0"/>
+              <a:t>3/8/2026</a:t>
+            </a:fld>
+            <a:endParaRPr lang="en-US"/>
+          </a:p>
+        </p:txBody>
+      </p:sp>
+      <p:sp>
+        <p:nvSpPr>
+          <p:cNvPr id="4" name="Slide Image Placeholder 3"/>
+          <p:cNvSpPr>
+            <a:spLocks noGrp="1" noRot="1" noChangeAspect="1"/>
+          </p:cNvSpPr>
+          <p:nvPr>
+            <p:ph type="sldImg" idx="2"/>
+          </p:nvPr>
+        </p:nvSpPr>
+        <p:spPr>
+          <a:xfrm>
+            <a:off x="746125" y="1181100"/>
+            <a:ext cx="5670550" cy="3189288"/>
+          </a:xfrm>
+          <a:prstGeom prst="rect">
+            <a:avLst/>
+          </a:prstGeom>
+          <a:noFill/>
+          <a:ln w="12700">
+            <a:solidFill>
+              <a:prstClr val="black"/>
+            </a:solidFill>
+          </a:ln>
+        </p:spPr>
+        <p:txBody>
+          <a:bodyPr vert="horz" lIns="91440" tIns="45720" rIns="91440" bIns="45720" rtlCol="0" anchor="ctr"/>
+          <a:lstStyle/>
+          <a:p>
+            <a:endParaRPr lang="en-US"/>
+          </a:p>
+        </p:txBody>
+      </p:sp>
+      <p:sp>
+        <p:nvSpPr>
+          <p:cNvPr id="5" name="Notes Placeholder 4"/>
+          <p:cNvSpPr>
+            <a:spLocks noGrp="1"/>
+          </p:cNvSpPr>
+          <p:nvPr>
+            <p:ph type="body" sz="quarter" idx="3"/>
+          </p:nvPr>
+        </p:nvSpPr>
+        <p:spPr>
+          <a:xfrm>
+            <a:off x="715963" y="4546600"/>
+            <a:ext cx="5730875" cy="3721100"/>
+          </a:xfrm>
+          <a:prstGeom prst="rect">
+            <a:avLst/>
+          </a:prstGeom>
+        </p:spPr>
+        <p:txBody>
+          <a:bodyPr vert="horz" lIns="91440" tIns="45720" rIns="91440" bIns="45720" rtlCol="0"/>
+          <a:lstStyle/>
+          <a:p>
+            <a:pPr lvl="0"/>
+            <a:r>
+              <a:rPr lang="en-US"/>
+              <a:t>Click to edit Master text styles</a:t>
+            </a:r>
+          </a:p>
+          <a:p>
+            <a:pPr lvl="1"/>
+            <a:r>
+              <a:rPr lang="en-US"/>
+              <a:t>Second level</a:t>
+            </a:r>
+          </a:p>
+          <a:p>
+            <a:pPr lvl="2"/>
+            <a:r>
+              <a:rPr lang="en-US"/>
+              <a:t>Third level</a:t>
+            </a:r>
+          </a:p>
+          <a:p>
+            <a:pPr lvl="3"/>
+            <a:r>
+              <a:rPr lang="en-US"/>
+              <a:t>Fourth level</a:t>
+            </a:r>
+          </a:p>
+          <a:p>
+            <a:pPr lvl="4"/>
+            <a:r>
+              <a:rPr lang="en-US"/>
+              <a:t>Fifth level</a:t>
+            </a:r>
+          </a:p>
+        </p:txBody>
+      </p:sp>
+      <p:sp>
+        <p:nvSpPr>
+          <p:cNvPr id="6" name="Footer Placeholder 5"/>
+          <p:cNvSpPr>
+            <a:spLocks noGrp="1"/>
+          </p:cNvSpPr>
+          <p:nvPr>
+            <p:ph type="ftr" sz="quarter" idx="4"/>
+          </p:nvPr>
+        </p:nvSpPr>
+        <p:spPr>
+          <a:xfrm>
+            <a:off x="0" y="8975725"/>
+            <a:ext cx="3103563" cy="473075"/>
+          </a:xfrm>
+          <a:prstGeom prst="rect">
+            <a:avLst/>
+          </a:prstGeom>
+        </p:spPr>
+        <p:txBody>
+          <a:bodyPr vert="horz" lIns="91440" tIns="45720" rIns="91440" bIns="45720" rtlCol="0" anchor="b"/>
+          <a:lstStyle>
+            <a:lvl1pPr algn="l">
+              <a:defRPr sz="1200"/>
+            </a:lvl1pPr>
+          </a:lstStyle>
+          <a:p>
+            <a:endParaRPr lang="en-US"/>
+          </a:p>
+        </p:txBody>
+      </p:sp>
+      <p:sp>
+        <p:nvSpPr>
+          <p:cNvPr id="7" name="Slide Number Placeholder 6"/>
+          <p:cNvSpPr>
+            <a:spLocks noGrp="1"/>
+          </p:cNvSpPr>
+          <p:nvPr>
+            <p:ph type="sldNum" sz="quarter" idx="5"/>
+          </p:nvPr>
+        </p:nvSpPr>
+        <p:spPr>
+          <a:xfrm>
+            <a:off x="4057650" y="8975725"/>
+            <a:ext cx="3103563" cy="473075"/>
+          </a:xfrm>
+          <a:prstGeom prst="rect">
+            <a:avLst/>
+          </a:prstGeom>
+        </p:spPr>
+        <p:txBody>
+          <a:bodyPr vert="horz" lIns="91440" tIns="45720" rIns="91440" bIns="45720" rtlCol="0" anchor="b"/>
+          <a:lstStyle>
+            <a:lvl1pPr algn="r">
+              <a:defRPr sz="1200"/>
+            </a:lvl1pPr>
+          </a:lstStyle>
+          <a:p>
+            <a:fld id="{22A778D6-196F-4B1A-863D-D35A5176F079}" type="slidenum">
+              <a:rPr lang="en-US" smtClean="0"/>
+              <a:t>‹#›</a:t>
+            </a:fld>
+            <a:endParaRPr lang="en-US"/>
+          </a:p>
+        </p:txBody>
+      </p:sp>
+    </p:spTree>
+    <p:extLst>
+      <p:ext uri="{BB962C8B-B14F-4D97-AF65-F5344CB8AC3E}">
+        <p14:creationId xmlns:p14="http://schemas.microsoft.com/office/powerpoint/2010/main" val="1521173470"/>
+      </p:ext>
+    </p:extLst>
+  </p:cSld>
+  <p:clrMap bg1="lt1" tx1="dk1" bg2="lt2" tx2="dk2" accent1="accent1" accent2="accent2" accent3="accent3" accent4="accent4" accent5="accent5" accent6="accent6" hlink="hlink" folHlink="folHlink"/>
+  <p:notesStyle>
+    <a:lvl1pPr marL="0" algn="l" defTabSz="914400" rtl="0" eaLnBrk="1" latinLnBrk="0" hangingPunct="1">
+      <a:defRPr sz="1200" kern="1200">
+        <a:solidFill>
+          <a:schemeClr val="tx1"/>
+        </a:solidFill>
+        <a:latin typeface="+mn-lt"/>
+        <a:ea typeface="+mn-ea"/>
+        <a:cs typeface="+mn-cs"/>
+      </a:defRPr>
+    </a:lvl1pPr>
+    <a:lvl2pPr marL="457200" algn="l" defTabSz="914400" rtl="0" eaLnBrk="1" latinLnBrk="0" hangingPunct="1">
+      <a:defRPr sz="1200" kern="1200">
+        <a:solidFill>
+          <a:schemeClr val="tx1"/>
+        </a:solidFill>
+        <a:latin typeface="+mn-lt"/>
+        <a:ea typeface="+mn-ea"/>
+        <a:cs typeface="+mn-cs"/>
+      </a:defRPr>
+    </a:lvl2pPr>
+    <a:lvl3pPr marL="914400" algn="l" defTabSz="914400" rtl="0" eaLnBrk="1" latinLnBrk="0" hangingPunct="1">
+      <a:defRPr sz="1200" kern="1200">
+        <a:solidFill>
+          <a:schemeClr val="tx1"/>
+        </a:solidFill>
+        <a:latin typeface="+mn-lt"/>
+        <a:ea typeface="+mn-ea"/>
+        <a:cs typeface="+mn-cs"/>
+      </a:defRPr>
+    </a:lvl3pPr>
+    <a:lvl4pPr marL="1371600" algn="l" defTabSz="914400" rtl="0" eaLnBrk="1" latinLnBrk="0" hangingPunct="1">
+      <a:defRPr sz="1200" kern="1200">
+        <a:solidFill>
+          <a:schemeClr val="tx1"/>
+        </a:solidFill>
+        <a:latin typeface="+mn-lt"/>
+        <a:ea typeface="+mn-ea"/>
+        <a:cs typeface="+mn-cs"/>
+      </a:defRPr>
+    </a:lvl4pPr>
+    <a:lvl5pPr marL="1828800" algn="l" defTabSz="914400" rtl="0" eaLnBrk="1" latinLnBrk="0" hangingPunct="1">
+      <a:defRPr sz="1200" kern="1200">
+        <a:solidFill>
+          <a:schemeClr val="tx1"/>
+        </a:solidFill>
+        <a:latin typeface="+mn-lt"/>
+        <a:ea typeface="+mn-ea"/>
+        <a:cs typeface="+mn-cs"/>
+      </a:defRPr>
+    </a:lvl5pPr>
+    <a:lvl6pPr marL="2286000" algn="l" defTabSz="914400" rtl="0" eaLnBrk="1" latinLnBrk="0" hangingPunct="1">
+      <a:defRPr sz="1200" kern="1200">
+        <a:solidFill>
+          <a:schemeClr val="tx1"/>
+        </a:solidFill>
+        <a:latin typeface="+mn-lt"/>
+        <a:ea typeface="+mn-ea"/>
+        <a:cs typeface="+mn-cs"/>
+      </a:defRPr>
+    </a:lvl6pPr>
+    <a:lvl7pPr marL="2743200" algn="l" defTabSz="914400" rtl="0" eaLnBrk="1" latinLnBrk="0" hangingPunct="1">
+      <a:defRPr sz="1200" kern="1200">
+        <a:solidFill>
+          <a:schemeClr val="tx1"/>
+        </a:solidFill>
+        <a:latin typeface="+mn-lt"/>
+        <a:ea typeface="+mn-ea"/>
+        <a:cs typeface="+mn-cs"/>
+      </a:defRPr>
+    </a:lvl7pPr>
+    <a:lvl8pPr marL="3200400" algn="l" defTabSz="914400" rtl="0" eaLnBrk="1" latinLnBrk="0" hangingPunct="1">
+      <a:defRPr sz="1200" kern="1200">
+        <a:solidFill>
+          <a:schemeClr val="tx1"/>
+        </a:solidFill>
+        <a:latin typeface="+mn-lt"/>
+        <a:ea typeface="+mn-ea"/>
+        <a:cs typeface="+mn-cs"/>
+      </a:defRPr>
+    </a:lvl8pPr>
+    <a:lvl9pPr marL="3657600" algn="l" defTabSz="914400" rtl="0" eaLnBrk="1" latinLnBrk="0" hangingPunct="1">
+      <a:defRPr sz="1200" kern="1200">
+        <a:solidFill>
+          <a:schemeClr val="tx1"/>
+        </a:solidFill>
+        <a:latin typeface="+mn-lt"/>
+        <a:ea typeface="+mn-ea"/>
+        <a:cs typeface="+mn-cs"/>
+      </a:defRPr>
+    </a:lvl9pPr>
+  </p:notesStyle>
+</p:notesMaster>
+</file>
+
+<file path=ppt/notesSlides/notesSlide1.xml><?xml version="1.0" encoding="utf-8"?>
+<p:notes xmlns:a="http://schemas.openxmlformats.org/drawingml/2006/main" xmlns:r="http://schemas.openxmlformats.org/officeDocument/2006/relationships" xmlns:p="http://schemas.openxmlformats.org/presentationml/2006/main">
+  <p:cSld>
+    <p:spTree>
+      <p:nvGrpSpPr>
+        <p:cNvPr id="1" name=""/>
+        <p:cNvGrpSpPr/>
+        <p:nvPr/>
+      </p:nvGrpSpPr>
+      <p:grpSpPr>
+        <a:xfrm>
+          <a:off x="0" y="0"/>
+          <a:ext cx="0" cy="0"/>
+          <a:chOff x="0" y="0"/>
+          <a:chExt cx="0" cy="0"/>
+        </a:xfrm>
+      </p:grpSpPr>
+      <p:sp>
+        <p:nvSpPr>
+          <p:cNvPr id="2" name="Slide Image Placeholder 1"/>
+          <p:cNvSpPr>
+            <a:spLocks noGrp="1" noRot="1" noChangeAspect="1"/>
+          </p:cNvSpPr>
+          <p:nvPr>
+            <p:ph type="sldImg"/>
+          </p:nvPr>
+        </p:nvSpPr>
+        <p:spPr/>
+      </p:sp>
+      <p:sp>
+        <p:nvSpPr>
+          <p:cNvPr id="3" name="Notes Placeholder 2"/>
+          <p:cNvSpPr>
+            <a:spLocks noGrp="1"/>
+          </p:cNvSpPr>
+          <p:nvPr>
+            <p:ph type="body" idx="1"/>
+          </p:nvPr>
+        </p:nvSpPr>
+        <p:spPr/>
+        <p:txBody>
+          <a:bodyPr/>
+          <a:lstStyle/>
+          <a:p>
+            <a:endParaRPr lang="en-US" dirty="0"/>
+          </a:p>
+        </p:txBody>
+      </p:sp>
+      <p:sp>
+        <p:nvSpPr>
+          <p:cNvPr id="4" name="Slide Number Placeholder 3"/>
+          <p:cNvSpPr>
+            <a:spLocks noGrp="1"/>
+          </p:cNvSpPr>
+          <p:nvPr>
+            <p:ph type="sldNum" sz="quarter" idx="5"/>
+          </p:nvPr>
+        </p:nvSpPr>
+        <p:spPr/>
+        <p:txBody>
+          <a:bodyPr/>
+          <a:lstStyle/>
+          <a:p>
+            <a:fld id="{22A778D6-196F-4B1A-863D-D35A5176F079}" type="slidenum">
+              <a:rPr lang="en-US" smtClean="0"/>
+              <a:t>1</a:t>
+            </a:fld>
+            <a:endParaRPr lang="en-US"/>
+          </a:p>
+        </p:txBody>
+      </p:sp>
+    </p:spTree>
+    <p:extLst>
+      <p:ext uri="{BB962C8B-B14F-4D97-AF65-F5344CB8AC3E}">
+        <p14:creationId xmlns:p14="http://schemas.microsoft.com/office/powerpoint/2010/main" val="3105852061"/>
+      </p:ext>
+    </p:extLst>
+  </p:cSld>
+  <p:clrMapOvr>
+    <a:masterClrMapping/>
+  </p:clrMapOvr>
+</p:notes>
+</file>
+
 <file path=ppt/slideLayouts/slideLayout1.xml><?xml version="1.0" encoding="utf-8"?>
 <p:sldLayout xmlns:a="http://schemas.openxmlformats.org/drawingml/2006/main" xmlns:r="http://schemas.openxmlformats.org/officeDocument/2006/relationships" xmlns:p="http://schemas.openxmlformats.org/presentationml/2006/main" type="title" preserve="1">
   <p:cSld name="Title Slide">
@@ -259,7 +695,7 @@
           <a:p>
             <a:fld id="{51AFF834-1BEC-4F95-9622-28B5DCC1FE16}" type="datetimeFigureOut">
               <a:rPr lang="en-US" smtClean="0"/>
-              <a:t>7/1/2025</a:t>
+              <a:t>3/8/2026</a:t>
             </a:fld>
             <a:endParaRPr lang="en-US"/>
           </a:p>
@@ -457,7 +893,7 @@
           <a:p>
             <a:fld id="{51AFF834-1BEC-4F95-9622-28B5DCC1FE16}" type="datetimeFigureOut">
               <a:rPr lang="en-US" smtClean="0"/>
-              <a:t>7/1/2025</a:t>
+              <a:t>3/8/2026</a:t>
             </a:fld>
             <a:endParaRPr lang="en-US"/>
           </a:p>
@@ -665,7 +1101,7 @@
           <a:p>
             <a:fld id="{51AFF834-1BEC-4F95-9622-28B5DCC1FE16}" type="datetimeFigureOut">
               <a:rPr lang="en-US" smtClean="0"/>
-              <a:t>7/1/2025</a:t>
+              <a:t>3/8/2026</a:t>
             </a:fld>
             <a:endParaRPr lang="en-US"/>
           </a:p>
@@ -863,7 +1299,7 @@
           <a:p>
             <a:fld id="{51AFF834-1BEC-4F95-9622-28B5DCC1FE16}" type="datetimeFigureOut">
               <a:rPr lang="en-US" smtClean="0"/>
-              <a:t>7/1/2025</a:t>
+              <a:t>3/8/2026</a:t>
             </a:fld>
             <a:endParaRPr lang="en-US"/>
           </a:p>
@@ -1138,7 +1574,7 @@
           <a:p>
             <a:fld id="{51AFF834-1BEC-4F95-9622-28B5DCC1FE16}" type="datetimeFigureOut">
               <a:rPr lang="en-US" smtClean="0"/>
-              <a:t>7/1/2025</a:t>
+              <a:t>3/8/2026</a:t>
             </a:fld>
             <a:endParaRPr lang="en-US"/>
           </a:p>
@@ -1403,7 +1839,7 @@
           <a:p>
             <a:fld id="{51AFF834-1BEC-4F95-9622-28B5DCC1FE16}" type="datetimeFigureOut">
               <a:rPr lang="en-US" smtClean="0"/>
-              <a:t>7/1/2025</a:t>
+              <a:t>3/8/2026</a:t>
             </a:fld>
             <a:endParaRPr lang="en-US"/>
           </a:p>
@@ -1815,7 +2251,7 @@
           <a:p>
             <a:fld id="{51AFF834-1BEC-4F95-9622-28B5DCC1FE16}" type="datetimeFigureOut">
               <a:rPr lang="en-US" smtClean="0"/>
-              <a:t>7/1/2025</a:t>
+              <a:t>3/8/2026</a:t>
             </a:fld>
             <a:endParaRPr lang="en-US"/>
           </a:p>
@@ -1956,7 +2392,7 @@
           <a:p>
             <a:fld id="{51AFF834-1BEC-4F95-9622-28B5DCC1FE16}" type="datetimeFigureOut">
               <a:rPr lang="en-US" smtClean="0"/>
-              <a:t>7/1/2025</a:t>
+              <a:t>3/8/2026</a:t>
             </a:fld>
             <a:endParaRPr lang="en-US"/>
           </a:p>
@@ -2069,7 +2505,7 @@
           <a:p>
             <a:fld id="{51AFF834-1BEC-4F95-9622-28B5DCC1FE16}" type="datetimeFigureOut">
               <a:rPr lang="en-US" smtClean="0"/>
-              <a:t>7/1/2025</a:t>
+              <a:t>3/8/2026</a:t>
             </a:fld>
             <a:endParaRPr lang="en-US"/>
           </a:p>
@@ -2380,7 +2816,7 @@
           <a:p>
             <a:fld id="{51AFF834-1BEC-4F95-9622-28B5DCC1FE16}" type="datetimeFigureOut">
               <a:rPr lang="en-US" smtClean="0"/>
-              <a:t>7/1/2025</a:t>
+              <a:t>3/8/2026</a:t>
             </a:fld>
             <a:endParaRPr lang="en-US"/>
           </a:p>
@@ -2668,7 +3104,7 @@
           <a:p>
             <a:fld id="{51AFF834-1BEC-4F95-9622-28B5DCC1FE16}" type="datetimeFigureOut">
               <a:rPr lang="en-US" smtClean="0"/>
-              <a:t>7/1/2025</a:t>
+              <a:t>3/8/2026</a:t>
             </a:fld>
             <a:endParaRPr lang="en-US"/>
           </a:p>
@@ -2909,7 +3345,7 @@
           <a:p>
             <a:fld id="{51AFF834-1BEC-4F95-9622-28B5DCC1FE16}" type="datetimeFigureOut">
               <a:rPr lang="en-US" smtClean="0"/>
-              <a:t>7/1/2025</a:t>
+              <a:t>3/8/2026</a:t>
             </a:fld>
             <a:endParaRPr lang="en-US"/>
           </a:p>
@@ -5317,50 +5753,6 @@
           </a:fontRef>
         </p:style>
       </p:cxnSp>
-      <p:cxnSp>
-        <p:nvCxnSpPr>
-          <p:cNvPr id="89" name="Straight Arrow Connector 88">
-            <a:extLst>
-              <a:ext uri="{FF2B5EF4-FFF2-40B4-BE49-F238E27FC236}">
-                <a16:creationId xmlns:a16="http://schemas.microsoft.com/office/drawing/2014/main" id="{F54A266D-F4C6-7070-9203-F459E46AE102}"/>
-              </a:ext>
-            </a:extLst>
-          </p:cNvPr>
-          <p:cNvCxnSpPr>
-            <a:cxnSpLocks/>
-          </p:cNvCxnSpPr>
-          <p:nvPr/>
-        </p:nvCxnSpPr>
-        <p:spPr>
-          <a:xfrm>
-            <a:off x="2572114" y="4519030"/>
-            <a:ext cx="475825" cy="0"/>
-          </a:xfrm>
-          <a:prstGeom prst="straightConnector1">
-            <a:avLst/>
-          </a:prstGeom>
-          <a:ln>
-            <a:solidFill>
-              <a:srgbClr val="FF0000"/>
-            </a:solidFill>
-            <a:tailEnd type="triangle"/>
-          </a:ln>
-        </p:spPr>
-        <p:style>
-          <a:lnRef idx="2">
-            <a:schemeClr val="accent1"/>
-          </a:lnRef>
-          <a:fillRef idx="0">
-            <a:schemeClr val="accent1"/>
-          </a:fillRef>
-          <a:effectRef idx="1">
-            <a:schemeClr val="accent1"/>
-          </a:effectRef>
-          <a:fontRef idx="minor">
-            <a:schemeClr val="tx1"/>
-          </a:fontRef>
-        </p:style>
-      </p:cxnSp>
       <p:sp>
         <p:nvSpPr>
           <p:cNvPr id="90" name="Rectangle 89">
@@ -5918,13 +6310,15 @@
               </a:ext>
             </a:extLst>
           </p:cNvPr>
-          <p:cNvCxnSpPr/>
+          <p:cNvCxnSpPr>
+            <a:cxnSpLocks/>
+          </p:cNvCxnSpPr>
           <p:nvPr/>
         </p:nvCxnSpPr>
         <p:spPr>
           <a:xfrm>
-            <a:off x="3216369" y="3387564"/>
-            <a:ext cx="177808" cy="0"/>
+            <a:off x="3047939" y="3387564"/>
+            <a:ext cx="346238" cy="0"/>
           </a:xfrm>
           <a:prstGeom prst="straightConnector1">
             <a:avLst/>
@@ -6246,78 +6640,6 @@
           </a:fontRef>
         </p:style>
       </p:cxnSp>
-      <p:cxnSp>
-        <p:nvCxnSpPr>
-          <p:cNvPr id="126" name="Straight Connector 125">
-            <a:extLst>
-              <a:ext uri="{FF2B5EF4-FFF2-40B4-BE49-F238E27FC236}">
-                <a16:creationId xmlns:a16="http://schemas.microsoft.com/office/drawing/2014/main" id="{D7619A53-5593-55CA-7ECB-A72DC2C2AB4D}"/>
-              </a:ext>
-            </a:extLst>
-          </p:cNvPr>
-          <p:cNvCxnSpPr/>
-          <p:nvPr/>
-        </p:nvCxnSpPr>
-        <p:spPr>
-          <a:xfrm flipH="1">
-            <a:off x="2754790" y="4454260"/>
-            <a:ext cx="77899" cy="129540"/>
-          </a:xfrm>
-          <a:prstGeom prst="line">
-            <a:avLst/>
-          </a:prstGeom>
-        </p:spPr>
-        <p:style>
-          <a:lnRef idx="2">
-            <a:schemeClr val="accent1"/>
-          </a:lnRef>
-          <a:fillRef idx="0">
-            <a:schemeClr val="accent1"/>
-          </a:fillRef>
-          <a:effectRef idx="1">
-            <a:schemeClr val="accent1"/>
-          </a:effectRef>
-          <a:fontRef idx="minor">
-            <a:schemeClr val="tx1"/>
-          </a:fontRef>
-        </p:style>
-      </p:cxnSp>
-      <p:sp>
-        <p:nvSpPr>
-          <p:cNvPr id="127" name="TextBox 126">
-            <a:extLst>
-              <a:ext uri="{FF2B5EF4-FFF2-40B4-BE49-F238E27FC236}">
-                <a16:creationId xmlns:a16="http://schemas.microsoft.com/office/drawing/2014/main" id="{E8F9A210-9B95-3371-FB33-95617722EA31}"/>
-              </a:ext>
-            </a:extLst>
-          </p:cNvPr>
-          <p:cNvSpPr txBox="1"/>
-          <p:nvPr/>
-        </p:nvSpPr>
-        <p:spPr>
-          <a:xfrm>
-            <a:off x="2639349" y="4330630"/>
-            <a:ext cx="245580" cy="230832"/>
-          </a:xfrm>
-          <a:prstGeom prst="rect">
-            <a:avLst/>
-          </a:prstGeom>
-          <a:noFill/>
-        </p:spPr>
-        <p:txBody>
-          <a:bodyPr wrap="none" rtlCol="0">
-            <a:spAutoFit/>
-          </a:bodyPr>
-          <a:lstStyle/>
-          <a:p>
-            <a:pPr algn="ctr"/>
-            <a:r>
-              <a:rPr lang="en-US" sz="900" dirty="0"/>
-              <a:t>7</a:t>
-            </a:r>
-          </a:p>
-        </p:txBody>
-      </p:sp>
       <p:sp>
         <p:nvSpPr>
           <p:cNvPr id="129" name="Rectangle 128">
@@ -8431,13 +8753,15 @@
               </a:ext>
             </a:extLst>
           </p:cNvPr>
-          <p:cNvCxnSpPr/>
+          <p:cNvCxnSpPr>
+            <a:cxnSpLocks/>
+          </p:cNvCxnSpPr>
           <p:nvPr/>
         </p:nvCxnSpPr>
         <p:spPr>
           <a:xfrm flipV="1">
             <a:off x="8716191" y="2434882"/>
-            <a:ext cx="0" cy="167673"/>
+            <a:ext cx="0" cy="430333"/>
           </a:xfrm>
           <a:prstGeom prst="straightConnector1">
             <a:avLst/>
@@ -8667,7 +8991,11 @@
           <a:p>
             <a:pPr algn="ctr"/>
             <a:r>
-              <a:rPr lang="en-US" sz="900" dirty="0"/>
+              <a:rPr lang="en-US" sz="900" dirty="0">
+                <a:solidFill>
+                  <a:srgbClr val="FF0000"/>
+                </a:solidFill>
+              </a:rPr>
               <a:t>state</a:t>
             </a:r>
           </a:p>
@@ -9091,13 +9419,15 @@
               </a:ext>
             </a:extLst>
           </p:cNvPr>
-          <p:cNvCxnSpPr/>
+          <p:cNvCxnSpPr>
+            <a:cxnSpLocks/>
+          </p:cNvCxnSpPr>
           <p:nvPr/>
         </p:nvCxnSpPr>
         <p:spPr>
           <a:xfrm>
-            <a:off x="9506818" y="4099798"/>
-            <a:ext cx="0" cy="230832"/>
+            <a:off x="9506818" y="3801533"/>
+            <a:ext cx="0" cy="529097"/>
           </a:xfrm>
           <a:prstGeom prst="straightConnector1">
             <a:avLst/>
@@ -9861,7 +10191,7 @@
         <p:spPr>
           <a:xfrm flipV="1">
             <a:off x="10852467" y="3154000"/>
-            <a:ext cx="0" cy="195214"/>
+            <a:ext cx="0" cy="893113"/>
           </a:xfrm>
           <a:prstGeom prst="straightConnector1">
             <a:avLst/>
@@ -10255,6 +10585,1946 @@
             <a:r>
               <a:rPr lang="en-US" sz="1000" dirty="0"/>
               <a:t>ALU</a:t>
+            </a:r>
+          </a:p>
+        </p:txBody>
+      </p:sp>
+      <p:sp>
+        <p:nvSpPr>
+          <p:cNvPr id="3" name="TextBox 2">
+            <a:extLst>
+              <a:ext uri="{FF2B5EF4-FFF2-40B4-BE49-F238E27FC236}">
+                <a16:creationId xmlns:a16="http://schemas.microsoft.com/office/drawing/2014/main" id="{47E076D1-624A-91F1-C2EB-5334C4C179BD}"/>
+              </a:ext>
+            </a:extLst>
+          </p:cNvPr>
+          <p:cNvSpPr txBox="1"/>
+          <p:nvPr/>
+        </p:nvSpPr>
+        <p:spPr>
+          <a:xfrm>
+            <a:off x="9584380" y="3685674"/>
+            <a:ext cx="436338" cy="230832"/>
+          </a:xfrm>
+          <a:prstGeom prst="rect">
+            <a:avLst/>
+          </a:prstGeom>
+          <a:noFill/>
+        </p:spPr>
+        <p:txBody>
+          <a:bodyPr wrap="none" rtlCol="0">
+            <a:spAutoFit/>
+          </a:bodyPr>
+          <a:lstStyle/>
+          <a:p>
+            <a:pPr algn="ctr"/>
+            <a:r>
+              <a:rPr lang="en-US" sz="900" dirty="0">
+                <a:solidFill>
+                  <a:srgbClr val="FF0000"/>
+                </a:solidFill>
+              </a:rPr>
+              <a:t>state</a:t>
+            </a:r>
+          </a:p>
+        </p:txBody>
+      </p:sp>
+      <p:sp>
+        <p:nvSpPr>
+          <p:cNvPr id="17" name="TextBox 16">
+            <a:extLst>
+              <a:ext uri="{FF2B5EF4-FFF2-40B4-BE49-F238E27FC236}">
+                <a16:creationId xmlns:a16="http://schemas.microsoft.com/office/drawing/2014/main" id="{BC0106CD-BCC5-5515-8E64-D2341CB1320D}"/>
+              </a:ext>
+            </a:extLst>
+          </p:cNvPr>
+          <p:cNvSpPr txBox="1"/>
+          <p:nvPr/>
+        </p:nvSpPr>
+        <p:spPr>
+          <a:xfrm>
+            <a:off x="8687894" y="3367023"/>
+            <a:ext cx="679994" cy="230832"/>
+          </a:xfrm>
+          <a:prstGeom prst="rect">
+            <a:avLst/>
+          </a:prstGeom>
+          <a:noFill/>
+        </p:spPr>
+        <p:txBody>
+          <a:bodyPr wrap="none" rtlCol="0">
+            <a:spAutoFit/>
+          </a:bodyPr>
+          <a:lstStyle/>
+          <a:p>
+            <a:pPr algn="ctr"/>
+            <a:r>
+              <a:rPr lang="en-US" sz="900" dirty="0" err="1">
+                <a:solidFill>
+                  <a:srgbClr val="FF0000"/>
+                </a:solidFill>
+              </a:rPr>
+              <a:t>alu_result</a:t>
+            </a:r>
+            <a:endParaRPr lang="en-US" sz="900" dirty="0">
+              <a:solidFill>
+                <a:srgbClr val="FF0000"/>
+              </a:solidFill>
+            </a:endParaRPr>
+          </a:p>
+        </p:txBody>
+      </p:sp>
+      <p:cxnSp>
+        <p:nvCxnSpPr>
+          <p:cNvPr id="19" name="Straight Arrow Connector 18">
+            <a:extLst>
+              <a:ext uri="{FF2B5EF4-FFF2-40B4-BE49-F238E27FC236}">
+                <a16:creationId xmlns:a16="http://schemas.microsoft.com/office/drawing/2014/main" id="{CF1F530C-9DCF-5A7D-D30B-707878F3550A}"/>
+              </a:ext>
+            </a:extLst>
+          </p:cNvPr>
+          <p:cNvCxnSpPr>
+            <a:cxnSpLocks/>
+          </p:cNvCxnSpPr>
+          <p:nvPr/>
+        </p:nvCxnSpPr>
+        <p:spPr>
+          <a:xfrm>
+            <a:off x="3566640" y="5203184"/>
+            <a:ext cx="240113" cy="0"/>
+          </a:xfrm>
+          <a:prstGeom prst="straightConnector1">
+            <a:avLst/>
+          </a:prstGeom>
+          <a:ln>
+            <a:solidFill>
+              <a:srgbClr val="FF0000"/>
+            </a:solidFill>
+            <a:tailEnd type="triangle"/>
+          </a:ln>
+        </p:spPr>
+        <p:style>
+          <a:lnRef idx="2">
+            <a:schemeClr val="accent1"/>
+          </a:lnRef>
+          <a:fillRef idx="0">
+            <a:schemeClr val="accent1"/>
+          </a:fillRef>
+          <a:effectRef idx="1">
+            <a:schemeClr val="accent1"/>
+          </a:effectRef>
+          <a:fontRef idx="minor">
+            <a:schemeClr val="tx1"/>
+          </a:fontRef>
+        </p:style>
+      </p:cxnSp>
+      <p:sp>
+        <p:nvSpPr>
+          <p:cNvPr id="28" name="TextBox 27">
+            <a:extLst>
+              <a:ext uri="{FF2B5EF4-FFF2-40B4-BE49-F238E27FC236}">
+                <a16:creationId xmlns:a16="http://schemas.microsoft.com/office/drawing/2014/main" id="{7EE35FC4-53B9-2FF5-4610-3DF132F5F8D8}"/>
+              </a:ext>
+            </a:extLst>
+          </p:cNvPr>
+          <p:cNvSpPr txBox="1"/>
+          <p:nvPr/>
+        </p:nvSpPr>
+        <p:spPr>
+          <a:xfrm>
+            <a:off x="3734800" y="4348814"/>
+            <a:ext cx="718466" cy="230832"/>
+          </a:xfrm>
+          <a:prstGeom prst="rect">
+            <a:avLst/>
+          </a:prstGeom>
+          <a:noFill/>
+        </p:spPr>
+        <p:txBody>
+          <a:bodyPr wrap="none" rtlCol="0">
+            <a:spAutoFit/>
+          </a:bodyPr>
+          <a:lstStyle/>
+          <a:p>
+            <a:pPr algn="ctr"/>
+            <a:r>
+              <a:rPr lang="en-US" sz="900" dirty="0" err="1">
+                <a:solidFill>
+                  <a:srgbClr val="FF0000"/>
+                </a:solidFill>
+              </a:rPr>
+              <a:t>mem_read</a:t>
+            </a:r>
+            <a:endParaRPr lang="en-US" sz="900" dirty="0">
+              <a:solidFill>
+                <a:srgbClr val="FF0000"/>
+              </a:solidFill>
+            </a:endParaRPr>
+          </a:p>
+        </p:txBody>
+      </p:sp>
+      <p:sp>
+        <p:nvSpPr>
+          <p:cNvPr id="30" name="TextBox 29">
+            <a:extLst>
+              <a:ext uri="{FF2B5EF4-FFF2-40B4-BE49-F238E27FC236}">
+                <a16:creationId xmlns:a16="http://schemas.microsoft.com/office/drawing/2014/main" id="{A8BD35B7-0723-3F2D-5165-88EA8CBFA398}"/>
+              </a:ext>
+            </a:extLst>
+          </p:cNvPr>
+          <p:cNvSpPr txBox="1"/>
+          <p:nvPr/>
+        </p:nvSpPr>
+        <p:spPr>
+          <a:xfrm>
+            <a:off x="3749363" y="4474598"/>
+            <a:ext cx="740908" cy="230832"/>
+          </a:xfrm>
+          <a:prstGeom prst="rect">
+            <a:avLst/>
+          </a:prstGeom>
+          <a:noFill/>
+        </p:spPr>
+        <p:txBody>
+          <a:bodyPr wrap="none" rtlCol="0">
+            <a:spAutoFit/>
+          </a:bodyPr>
+          <a:lstStyle/>
+          <a:p>
+            <a:pPr algn="ctr"/>
+            <a:r>
+              <a:rPr lang="en-US" sz="900" dirty="0" err="1">
+                <a:solidFill>
+                  <a:srgbClr val="FF0000"/>
+                </a:solidFill>
+              </a:rPr>
+              <a:t>mem_write</a:t>
+            </a:r>
+            <a:endParaRPr lang="en-US" sz="900" dirty="0">
+              <a:solidFill>
+                <a:srgbClr val="FF0000"/>
+              </a:solidFill>
+            </a:endParaRPr>
+          </a:p>
+        </p:txBody>
+      </p:sp>
+      <p:sp>
+        <p:nvSpPr>
+          <p:cNvPr id="224" name="TextBox 223">
+            <a:extLst>
+              <a:ext uri="{FF2B5EF4-FFF2-40B4-BE49-F238E27FC236}">
+                <a16:creationId xmlns:a16="http://schemas.microsoft.com/office/drawing/2014/main" id="{7247B166-4106-5DC8-71E2-BA7999EB77F8}"/>
+              </a:ext>
+            </a:extLst>
+          </p:cNvPr>
+          <p:cNvSpPr txBox="1"/>
+          <p:nvPr/>
+        </p:nvSpPr>
+        <p:spPr>
+          <a:xfrm>
+            <a:off x="3755993" y="4589657"/>
+            <a:ext cx="548548" cy="230832"/>
+          </a:xfrm>
+          <a:prstGeom prst="rect">
+            <a:avLst/>
+          </a:prstGeom>
+          <a:noFill/>
+        </p:spPr>
+        <p:txBody>
+          <a:bodyPr wrap="none" rtlCol="0">
+            <a:spAutoFit/>
+          </a:bodyPr>
+          <a:lstStyle/>
+          <a:p>
+            <a:pPr algn="ctr"/>
+            <a:r>
+              <a:rPr lang="en-US" sz="900" dirty="0" err="1">
+                <a:solidFill>
+                  <a:srgbClr val="FF0000"/>
+                </a:solidFill>
+              </a:rPr>
+              <a:t>alu_src</a:t>
+            </a:r>
+            <a:endParaRPr lang="en-US" sz="900" dirty="0">
+              <a:solidFill>
+                <a:srgbClr val="FF0000"/>
+              </a:solidFill>
+            </a:endParaRPr>
+          </a:p>
+        </p:txBody>
+      </p:sp>
+      <p:sp>
+        <p:nvSpPr>
+          <p:cNvPr id="225" name="TextBox 224">
+            <a:extLst>
+              <a:ext uri="{FF2B5EF4-FFF2-40B4-BE49-F238E27FC236}">
+                <a16:creationId xmlns:a16="http://schemas.microsoft.com/office/drawing/2014/main" id="{D17B7223-994A-BF49-4D9F-7ABE560199FD}"/>
+              </a:ext>
+            </a:extLst>
+          </p:cNvPr>
+          <p:cNvSpPr txBox="1"/>
+          <p:nvPr/>
+        </p:nvSpPr>
+        <p:spPr>
+          <a:xfrm>
+            <a:off x="3753575" y="4711209"/>
+            <a:ext cx="537327" cy="230832"/>
+          </a:xfrm>
+          <a:prstGeom prst="rect">
+            <a:avLst/>
+          </a:prstGeom>
+          <a:noFill/>
+        </p:spPr>
+        <p:txBody>
+          <a:bodyPr wrap="none" rtlCol="0">
+            <a:spAutoFit/>
+          </a:bodyPr>
+          <a:lstStyle/>
+          <a:p>
+            <a:pPr algn="ctr"/>
+            <a:r>
+              <a:rPr lang="en-US" sz="900" dirty="0">
+                <a:solidFill>
+                  <a:srgbClr val="FF0000"/>
+                </a:solidFill>
+              </a:rPr>
+              <a:t>branch</a:t>
+            </a:r>
+          </a:p>
+        </p:txBody>
+      </p:sp>
+      <p:sp>
+        <p:nvSpPr>
+          <p:cNvPr id="226" name="TextBox 225">
+            <a:extLst>
+              <a:ext uri="{FF2B5EF4-FFF2-40B4-BE49-F238E27FC236}">
+                <a16:creationId xmlns:a16="http://schemas.microsoft.com/office/drawing/2014/main" id="{6D82ACFB-F52E-7550-79BD-9ED8066F74EA}"/>
+              </a:ext>
+            </a:extLst>
+          </p:cNvPr>
+          <p:cNvSpPr txBox="1"/>
+          <p:nvPr/>
+        </p:nvSpPr>
+        <p:spPr>
+          <a:xfrm>
+            <a:off x="3752355" y="4845880"/>
+            <a:ext cx="437941" cy="230832"/>
+          </a:xfrm>
+          <a:prstGeom prst="rect">
+            <a:avLst/>
+          </a:prstGeom>
+          <a:noFill/>
+        </p:spPr>
+        <p:txBody>
+          <a:bodyPr wrap="none" rtlCol="0">
+            <a:spAutoFit/>
+          </a:bodyPr>
+          <a:lstStyle/>
+          <a:p>
+            <a:pPr algn="ctr"/>
+            <a:r>
+              <a:rPr lang="en-US" sz="900" dirty="0">
+                <a:solidFill>
+                  <a:srgbClr val="FF0000"/>
+                </a:solidFill>
+              </a:rPr>
+              <a:t>jump</a:t>
+            </a:r>
+          </a:p>
+        </p:txBody>
+      </p:sp>
+      <p:sp>
+        <p:nvSpPr>
+          <p:cNvPr id="228" name="TextBox 227">
+            <a:extLst>
+              <a:ext uri="{FF2B5EF4-FFF2-40B4-BE49-F238E27FC236}">
+                <a16:creationId xmlns:a16="http://schemas.microsoft.com/office/drawing/2014/main" id="{EEAFD317-93B1-C6E4-E1FA-97F3D6619D4C}"/>
+              </a:ext>
+            </a:extLst>
+          </p:cNvPr>
+          <p:cNvSpPr txBox="1"/>
+          <p:nvPr/>
+        </p:nvSpPr>
+        <p:spPr>
+          <a:xfrm>
+            <a:off x="3750760" y="4968188"/>
+            <a:ext cx="684803" cy="230832"/>
+          </a:xfrm>
+          <a:prstGeom prst="rect">
+            <a:avLst/>
+          </a:prstGeom>
+          <a:noFill/>
+        </p:spPr>
+        <p:txBody>
+          <a:bodyPr wrap="none" rtlCol="0">
+            <a:spAutoFit/>
+          </a:bodyPr>
+          <a:lstStyle/>
+          <a:p>
+            <a:pPr algn="ctr"/>
+            <a:r>
+              <a:rPr lang="en-US" sz="900" dirty="0" err="1">
+                <a:solidFill>
+                  <a:srgbClr val="FF0000"/>
+                </a:solidFill>
+              </a:rPr>
+              <a:t>load_addr</a:t>
+            </a:r>
+            <a:endParaRPr lang="en-US" sz="900" dirty="0">
+              <a:solidFill>
+                <a:srgbClr val="FF0000"/>
+              </a:solidFill>
+            </a:endParaRPr>
+          </a:p>
+        </p:txBody>
+      </p:sp>
+      <p:sp>
+        <p:nvSpPr>
+          <p:cNvPr id="232" name="TextBox 231">
+            <a:extLst>
+              <a:ext uri="{FF2B5EF4-FFF2-40B4-BE49-F238E27FC236}">
+                <a16:creationId xmlns:a16="http://schemas.microsoft.com/office/drawing/2014/main" id="{9394C715-1C43-D51D-2DDC-0F1D87F24A53}"/>
+              </a:ext>
+            </a:extLst>
+          </p:cNvPr>
+          <p:cNvSpPr txBox="1"/>
+          <p:nvPr/>
+        </p:nvSpPr>
+        <p:spPr>
+          <a:xfrm>
+            <a:off x="3750353" y="5089071"/>
+            <a:ext cx="639919" cy="230832"/>
+          </a:xfrm>
+          <a:prstGeom prst="rect">
+            <a:avLst/>
+          </a:prstGeom>
+          <a:noFill/>
+        </p:spPr>
+        <p:txBody>
+          <a:bodyPr wrap="none" rtlCol="0">
+            <a:spAutoFit/>
+          </a:bodyPr>
+          <a:lstStyle/>
+          <a:p>
+            <a:pPr algn="ctr"/>
+            <a:r>
+              <a:rPr lang="en-US" sz="900" dirty="0" err="1">
+                <a:solidFill>
+                  <a:srgbClr val="FF0000"/>
+                </a:solidFill>
+              </a:rPr>
+              <a:t>reg_write</a:t>
+            </a:r>
+            <a:endParaRPr lang="en-US" sz="900" dirty="0">
+              <a:solidFill>
+                <a:srgbClr val="FF0000"/>
+              </a:solidFill>
+            </a:endParaRPr>
+          </a:p>
+        </p:txBody>
+      </p:sp>
+      <p:cxnSp>
+        <p:nvCxnSpPr>
+          <p:cNvPr id="234" name="Straight Connector 233">
+            <a:extLst>
+              <a:ext uri="{FF2B5EF4-FFF2-40B4-BE49-F238E27FC236}">
+                <a16:creationId xmlns:a16="http://schemas.microsoft.com/office/drawing/2014/main" id="{5D094692-BE93-1DAC-E4FF-FC3777BF74C2}"/>
+              </a:ext>
+            </a:extLst>
+          </p:cNvPr>
+          <p:cNvCxnSpPr>
+            <a:cxnSpLocks/>
+          </p:cNvCxnSpPr>
+          <p:nvPr/>
+        </p:nvCxnSpPr>
+        <p:spPr>
+          <a:xfrm>
+            <a:off x="3219011" y="3387564"/>
+            <a:ext cx="2047" cy="165301"/>
+          </a:xfrm>
+          <a:prstGeom prst="line">
+            <a:avLst/>
+          </a:prstGeom>
+          <a:ln>
+            <a:solidFill>
+              <a:srgbClr val="FF0000"/>
+            </a:solidFill>
+          </a:ln>
+        </p:spPr>
+        <p:style>
+          <a:lnRef idx="2">
+            <a:schemeClr val="accent1"/>
+          </a:lnRef>
+          <a:fillRef idx="0">
+            <a:schemeClr val="accent1"/>
+          </a:fillRef>
+          <a:effectRef idx="1">
+            <a:schemeClr val="accent1"/>
+          </a:effectRef>
+          <a:fontRef idx="minor">
+            <a:schemeClr val="tx1"/>
+          </a:fontRef>
+        </p:style>
+      </p:cxnSp>
+      <p:sp>
+        <p:nvSpPr>
+          <p:cNvPr id="244" name="TextBox 243">
+            <a:extLst>
+              <a:ext uri="{FF2B5EF4-FFF2-40B4-BE49-F238E27FC236}">
+                <a16:creationId xmlns:a16="http://schemas.microsoft.com/office/drawing/2014/main" id="{F294CEF6-CC56-973A-6385-08F8A45E38CB}"/>
+              </a:ext>
+            </a:extLst>
+          </p:cNvPr>
+          <p:cNvSpPr txBox="1"/>
+          <p:nvPr/>
+        </p:nvSpPr>
+        <p:spPr>
+          <a:xfrm>
+            <a:off x="2923305" y="3505807"/>
+            <a:ext cx="639919" cy="230832"/>
+          </a:xfrm>
+          <a:prstGeom prst="rect">
+            <a:avLst/>
+          </a:prstGeom>
+          <a:noFill/>
+        </p:spPr>
+        <p:txBody>
+          <a:bodyPr wrap="none" rtlCol="0">
+            <a:spAutoFit/>
+          </a:bodyPr>
+          <a:lstStyle/>
+          <a:p>
+            <a:pPr algn="ctr"/>
+            <a:r>
+              <a:rPr lang="en-US" sz="900" dirty="0" err="1">
+                <a:solidFill>
+                  <a:srgbClr val="FF0000"/>
+                </a:solidFill>
+              </a:rPr>
+              <a:t>reg_write</a:t>
+            </a:r>
+            <a:endParaRPr lang="en-US" sz="900" dirty="0">
+              <a:solidFill>
+                <a:srgbClr val="FF0000"/>
+              </a:solidFill>
+            </a:endParaRPr>
+          </a:p>
+        </p:txBody>
+      </p:sp>
+      <p:sp>
+        <p:nvSpPr>
+          <p:cNvPr id="246" name="TextBox 245">
+            <a:extLst>
+              <a:ext uri="{FF2B5EF4-FFF2-40B4-BE49-F238E27FC236}">
+                <a16:creationId xmlns:a16="http://schemas.microsoft.com/office/drawing/2014/main" id="{72905361-5316-460F-D8FC-F705FDF90646}"/>
+              </a:ext>
+            </a:extLst>
+          </p:cNvPr>
+          <p:cNvSpPr txBox="1"/>
+          <p:nvPr/>
+        </p:nvSpPr>
+        <p:spPr>
+          <a:xfrm>
+            <a:off x="2676618" y="3270519"/>
+            <a:ext cx="436338" cy="230832"/>
+          </a:xfrm>
+          <a:prstGeom prst="rect">
+            <a:avLst/>
+          </a:prstGeom>
+          <a:noFill/>
+        </p:spPr>
+        <p:txBody>
+          <a:bodyPr wrap="none" rtlCol="0">
+            <a:spAutoFit/>
+          </a:bodyPr>
+          <a:lstStyle/>
+          <a:p>
+            <a:pPr algn="ctr"/>
+            <a:r>
+              <a:rPr lang="en-US" sz="900" dirty="0">
+                <a:solidFill>
+                  <a:srgbClr val="FF0000"/>
+                </a:solidFill>
+              </a:rPr>
+              <a:t>state</a:t>
+            </a:r>
+          </a:p>
+        </p:txBody>
+      </p:sp>
+      <p:sp>
+        <p:nvSpPr>
+          <p:cNvPr id="252" name="TextBox 251">
+            <a:extLst>
+              <a:ext uri="{FF2B5EF4-FFF2-40B4-BE49-F238E27FC236}">
+                <a16:creationId xmlns:a16="http://schemas.microsoft.com/office/drawing/2014/main" id="{88F40F72-18D5-5002-5AD0-13171C5D004B}"/>
+              </a:ext>
+            </a:extLst>
+          </p:cNvPr>
+          <p:cNvSpPr txBox="1"/>
+          <p:nvPr/>
+        </p:nvSpPr>
+        <p:spPr>
+          <a:xfrm>
+            <a:off x="3247338" y="5250885"/>
+            <a:ext cx="521297" cy="230832"/>
+          </a:xfrm>
+          <a:prstGeom prst="rect">
+            <a:avLst/>
+          </a:prstGeom>
+          <a:noFill/>
+        </p:spPr>
+        <p:txBody>
+          <a:bodyPr wrap="none" rtlCol="0">
+            <a:spAutoFit/>
+          </a:bodyPr>
+          <a:lstStyle/>
+          <a:p>
+            <a:pPr algn="ctr"/>
+            <a:r>
+              <a:rPr lang="en-US" sz="900" dirty="0" err="1">
+                <a:solidFill>
+                  <a:srgbClr val="FF0000"/>
+                </a:solidFill>
+              </a:rPr>
+              <a:t>alu_op</a:t>
+            </a:r>
+            <a:endParaRPr lang="en-US" sz="900" dirty="0">
+              <a:solidFill>
+                <a:srgbClr val="FF0000"/>
+              </a:solidFill>
+            </a:endParaRPr>
+          </a:p>
+        </p:txBody>
+      </p:sp>
+      <p:sp>
+        <p:nvSpPr>
+          <p:cNvPr id="254" name="TextBox 253">
+            <a:extLst>
+              <a:ext uri="{FF2B5EF4-FFF2-40B4-BE49-F238E27FC236}">
+                <a16:creationId xmlns:a16="http://schemas.microsoft.com/office/drawing/2014/main" id="{A8D5493A-092F-0893-4989-D35CECB6DB67}"/>
+              </a:ext>
+            </a:extLst>
+          </p:cNvPr>
+          <p:cNvSpPr txBox="1"/>
+          <p:nvPr/>
+        </p:nvSpPr>
+        <p:spPr>
+          <a:xfrm>
+            <a:off x="5530564" y="3429000"/>
+            <a:ext cx="548548" cy="230832"/>
+          </a:xfrm>
+          <a:prstGeom prst="rect">
+            <a:avLst/>
+          </a:prstGeom>
+          <a:noFill/>
+        </p:spPr>
+        <p:txBody>
+          <a:bodyPr wrap="none" rtlCol="0">
+            <a:spAutoFit/>
+          </a:bodyPr>
+          <a:lstStyle/>
+          <a:p>
+            <a:pPr algn="ctr"/>
+            <a:r>
+              <a:rPr lang="en-US" sz="900" dirty="0" err="1">
+                <a:solidFill>
+                  <a:srgbClr val="FF0000"/>
+                </a:solidFill>
+              </a:rPr>
+              <a:t>alu_src</a:t>
+            </a:r>
+            <a:endParaRPr lang="en-US" sz="900" dirty="0">
+              <a:solidFill>
+                <a:srgbClr val="FF0000"/>
+              </a:solidFill>
+            </a:endParaRPr>
+          </a:p>
+        </p:txBody>
+      </p:sp>
+      <p:sp>
+        <p:nvSpPr>
+          <p:cNvPr id="255" name="TextBox 254">
+            <a:extLst>
+              <a:ext uri="{FF2B5EF4-FFF2-40B4-BE49-F238E27FC236}">
+                <a16:creationId xmlns:a16="http://schemas.microsoft.com/office/drawing/2014/main" id="{CD2EFC47-F982-0C19-6E30-D1024378A6E0}"/>
+              </a:ext>
+            </a:extLst>
+          </p:cNvPr>
+          <p:cNvSpPr txBox="1"/>
+          <p:nvPr/>
+        </p:nvSpPr>
+        <p:spPr>
+          <a:xfrm>
+            <a:off x="5984633" y="3367023"/>
+            <a:ext cx="521297" cy="230832"/>
+          </a:xfrm>
+          <a:prstGeom prst="rect">
+            <a:avLst/>
+          </a:prstGeom>
+          <a:noFill/>
+        </p:spPr>
+        <p:txBody>
+          <a:bodyPr wrap="none" rtlCol="0">
+            <a:spAutoFit/>
+          </a:bodyPr>
+          <a:lstStyle/>
+          <a:p>
+            <a:pPr algn="ctr"/>
+            <a:r>
+              <a:rPr lang="en-US" sz="900" dirty="0" err="1">
+                <a:solidFill>
+                  <a:srgbClr val="FF0000"/>
+                </a:solidFill>
+              </a:rPr>
+              <a:t>alu_op</a:t>
+            </a:r>
+            <a:endParaRPr lang="en-US" sz="900" dirty="0">
+              <a:solidFill>
+                <a:srgbClr val="FF0000"/>
+              </a:solidFill>
+            </a:endParaRPr>
+          </a:p>
+        </p:txBody>
+      </p:sp>
+      <p:sp>
+        <p:nvSpPr>
+          <p:cNvPr id="32" name="TextBox 31">
+            <a:extLst>
+              <a:ext uri="{FF2B5EF4-FFF2-40B4-BE49-F238E27FC236}">
+                <a16:creationId xmlns:a16="http://schemas.microsoft.com/office/drawing/2014/main" id="{A090903B-1B22-51E1-026D-2277A8A541C1}"/>
+              </a:ext>
+            </a:extLst>
+          </p:cNvPr>
+          <p:cNvSpPr txBox="1"/>
+          <p:nvPr/>
+        </p:nvSpPr>
+        <p:spPr>
+          <a:xfrm>
+            <a:off x="7917414" y="2540481"/>
+            <a:ext cx="718466" cy="230832"/>
+          </a:xfrm>
+          <a:prstGeom prst="rect">
+            <a:avLst/>
+          </a:prstGeom>
+          <a:noFill/>
+        </p:spPr>
+        <p:txBody>
+          <a:bodyPr wrap="none" rtlCol="0">
+            <a:spAutoFit/>
+          </a:bodyPr>
+          <a:lstStyle/>
+          <a:p>
+            <a:pPr algn="ctr"/>
+            <a:r>
+              <a:rPr lang="en-US" sz="900" dirty="0" err="1">
+                <a:solidFill>
+                  <a:srgbClr val="FF0000"/>
+                </a:solidFill>
+              </a:rPr>
+              <a:t>mem_read</a:t>
+            </a:r>
+            <a:endParaRPr lang="en-US" sz="900" dirty="0">
+              <a:solidFill>
+                <a:srgbClr val="FF0000"/>
+              </a:solidFill>
+            </a:endParaRPr>
+          </a:p>
+        </p:txBody>
+      </p:sp>
+      <p:cxnSp>
+        <p:nvCxnSpPr>
+          <p:cNvPr id="34" name="Straight Connector 33">
+            <a:extLst>
+              <a:ext uri="{FF2B5EF4-FFF2-40B4-BE49-F238E27FC236}">
+                <a16:creationId xmlns:a16="http://schemas.microsoft.com/office/drawing/2014/main" id="{F9F9357D-3E57-C790-540D-183FA1E5A444}"/>
+              </a:ext>
+            </a:extLst>
+          </p:cNvPr>
+          <p:cNvCxnSpPr>
+            <a:cxnSpLocks/>
+          </p:cNvCxnSpPr>
+          <p:nvPr/>
+        </p:nvCxnSpPr>
+        <p:spPr>
+          <a:xfrm>
+            <a:off x="8716501" y="2702044"/>
+            <a:ext cx="127262" cy="0"/>
+          </a:xfrm>
+          <a:prstGeom prst="line">
+            <a:avLst/>
+          </a:prstGeom>
+          <a:ln>
+            <a:solidFill>
+              <a:srgbClr val="FF0000"/>
+            </a:solidFill>
+          </a:ln>
+        </p:spPr>
+        <p:style>
+          <a:lnRef idx="2">
+            <a:schemeClr val="accent1"/>
+          </a:lnRef>
+          <a:fillRef idx="0">
+            <a:schemeClr val="accent1"/>
+          </a:fillRef>
+          <a:effectRef idx="1">
+            <a:schemeClr val="accent1"/>
+          </a:effectRef>
+          <a:fontRef idx="minor">
+            <a:schemeClr val="tx1"/>
+          </a:fontRef>
+        </p:style>
+      </p:cxnSp>
+      <p:cxnSp>
+        <p:nvCxnSpPr>
+          <p:cNvPr id="52" name="Straight Connector 51">
+            <a:extLst>
+              <a:ext uri="{FF2B5EF4-FFF2-40B4-BE49-F238E27FC236}">
+                <a16:creationId xmlns:a16="http://schemas.microsoft.com/office/drawing/2014/main" id="{633BC502-0FB6-830F-A8F7-0DDBA8C1983B}"/>
+              </a:ext>
+            </a:extLst>
+          </p:cNvPr>
+          <p:cNvCxnSpPr>
+            <a:cxnSpLocks/>
+          </p:cNvCxnSpPr>
+          <p:nvPr/>
+        </p:nvCxnSpPr>
+        <p:spPr>
+          <a:xfrm>
+            <a:off x="8707709" y="2865215"/>
+            <a:ext cx="127262" cy="0"/>
+          </a:xfrm>
+          <a:prstGeom prst="line">
+            <a:avLst/>
+          </a:prstGeom>
+          <a:ln>
+            <a:solidFill>
+              <a:srgbClr val="FF0000"/>
+            </a:solidFill>
+          </a:ln>
+        </p:spPr>
+        <p:style>
+          <a:lnRef idx="2">
+            <a:schemeClr val="accent1"/>
+          </a:lnRef>
+          <a:fillRef idx="0">
+            <a:schemeClr val="accent1"/>
+          </a:fillRef>
+          <a:effectRef idx="1">
+            <a:schemeClr val="accent1"/>
+          </a:effectRef>
+          <a:fontRef idx="minor">
+            <a:schemeClr val="tx1"/>
+          </a:fontRef>
+        </p:style>
+      </p:cxnSp>
+      <p:sp>
+        <p:nvSpPr>
+          <p:cNvPr id="53" name="TextBox 52">
+            <a:extLst>
+              <a:ext uri="{FF2B5EF4-FFF2-40B4-BE49-F238E27FC236}">
+                <a16:creationId xmlns:a16="http://schemas.microsoft.com/office/drawing/2014/main" id="{49935CC7-07AC-8C00-CE4E-9299D836874B}"/>
+              </a:ext>
+            </a:extLst>
+          </p:cNvPr>
+          <p:cNvSpPr txBox="1"/>
+          <p:nvPr/>
+        </p:nvSpPr>
+        <p:spPr>
+          <a:xfrm>
+            <a:off x="8780132" y="2741061"/>
+            <a:ext cx="740908" cy="230832"/>
+          </a:xfrm>
+          <a:prstGeom prst="rect">
+            <a:avLst/>
+          </a:prstGeom>
+          <a:noFill/>
+        </p:spPr>
+        <p:txBody>
+          <a:bodyPr wrap="none" rtlCol="0">
+            <a:spAutoFit/>
+          </a:bodyPr>
+          <a:lstStyle/>
+          <a:p>
+            <a:pPr algn="ctr"/>
+            <a:r>
+              <a:rPr lang="en-US" sz="900" dirty="0" err="1">
+                <a:solidFill>
+                  <a:srgbClr val="FF0000"/>
+                </a:solidFill>
+              </a:rPr>
+              <a:t>mem_write</a:t>
+            </a:r>
+            <a:endParaRPr lang="en-US" sz="900" dirty="0">
+              <a:solidFill>
+                <a:srgbClr val="FF0000"/>
+              </a:solidFill>
+            </a:endParaRPr>
+          </a:p>
+        </p:txBody>
+      </p:sp>
+      <p:sp>
+        <p:nvSpPr>
+          <p:cNvPr id="54" name="TextBox 53">
+            <a:extLst>
+              <a:ext uri="{FF2B5EF4-FFF2-40B4-BE49-F238E27FC236}">
+                <a16:creationId xmlns:a16="http://schemas.microsoft.com/office/drawing/2014/main" id="{DFF30B2F-233D-53DE-BE39-BD8B18651379}"/>
+              </a:ext>
+            </a:extLst>
+          </p:cNvPr>
+          <p:cNvSpPr txBox="1"/>
+          <p:nvPr/>
+        </p:nvSpPr>
+        <p:spPr>
+          <a:xfrm>
+            <a:off x="8787245" y="2586628"/>
+            <a:ext cx="436338" cy="230832"/>
+          </a:xfrm>
+          <a:prstGeom prst="rect">
+            <a:avLst/>
+          </a:prstGeom>
+          <a:noFill/>
+        </p:spPr>
+        <p:txBody>
+          <a:bodyPr wrap="none" rtlCol="0">
+            <a:spAutoFit/>
+          </a:bodyPr>
+          <a:lstStyle/>
+          <a:p>
+            <a:pPr algn="ctr"/>
+            <a:r>
+              <a:rPr lang="en-US" sz="900" dirty="0">
+                <a:solidFill>
+                  <a:srgbClr val="FF0000"/>
+                </a:solidFill>
+              </a:rPr>
+              <a:t>state</a:t>
+            </a:r>
+          </a:p>
+        </p:txBody>
+      </p:sp>
+      <p:cxnSp>
+        <p:nvCxnSpPr>
+          <p:cNvPr id="58" name="Straight Connector 57">
+            <a:extLst>
+              <a:ext uri="{FF2B5EF4-FFF2-40B4-BE49-F238E27FC236}">
+                <a16:creationId xmlns:a16="http://schemas.microsoft.com/office/drawing/2014/main" id="{A233B2C1-5DA0-E61E-5DAC-44DC37271334}"/>
+              </a:ext>
+            </a:extLst>
+          </p:cNvPr>
+          <p:cNvCxnSpPr>
+            <a:cxnSpLocks/>
+          </p:cNvCxnSpPr>
+          <p:nvPr/>
+        </p:nvCxnSpPr>
+        <p:spPr>
+          <a:xfrm>
+            <a:off x="10864679" y="3601867"/>
+            <a:ext cx="127262" cy="0"/>
+          </a:xfrm>
+          <a:prstGeom prst="line">
+            <a:avLst/>
+          </a:prstGeom>
+          <a:ln>
+            <a:solidFill>
+              <a:srgbClr val="FF0000"/>
+            </a:solidFill>
+          </a:ln>
+        </p:spPr>
+        <p:style>
+          <a:lnRef idx="2">
+            <a:schemeClr val="accent1"/>
+          </a:lnRef>
+          <a:fillRef idx="0">
+            <a:schemeClr val="accent1"/>
+          </a:fillRef>
+          <a:effectRef idx="1">
+            <a:schemeClr val="accent1"/>
+          </a:effectRef>
+          <a:fontRef idx="minor">
+            <a:schemeClr val="tx1"/>
+          </a:fontRef>
+        </p:style>
+      </p:cxnSp>
+      <p:cxnSp>
+        <p:nvCxnSpPr>
+          <p:cNvPr id="59" name="Straight Connector 58">
+            <a:extLst>
+              <a:ext uri="{FF2B5EF4-FFF2-40B4-BE49-F238E27FC236}">
+                <a16:creationId xmlns:a16="http://schemas.microsoft.com/office/drawing/2014/main" id="{B7C4E7E0-612A-CD13-D0AC-E0F91AA8D127}"/>
+              </a:ext>
+            </a:extLst>
+          </p:cNvPr>
+          <p:cNvCxnSpPr>
+            <a:cxnSpLocks/>
+          </p:cNvCxnSpPr>
+          <p:nvPr/>
+        </p:nvCxnSpPr>
+        <p:spPr>
+          <a:xfrm>
+            <a:off x="10860703" y="3748966"/>
+            <a:ext cx="127262" cy="0"/>
+          </a:xfrm>
+          <a:prstGeom prst="line">
+            <a:avLst/>
+          </a:prstGeom>
+          <a:ln>
+            <a:solidFill>
+              <a:srgbClr val="FF0000"/>
+            </a:solidFill>
+          </a:ln>
+        </p:spPr>
+        <p:style>
+          <a:lnRef idx="2">
+            <a:schemeClr val="accent1"/>
+          </a:lnRef>
+          <a:fillRef idx="0">
+            <a:schemeClr val="accent1"/>
+          </a:fillRef>
+          <a:effectRef idx="1">
+            <a:schemeClr val="accent1"/>
+          </a:effectRef>
+          <a:fontRef idx="minor">
+            <a:schemeClr val="tx1"/>
+          </a:fontRef>
+        </p:style>
+      </p:cxnSp>
+      <p:cxnSp>
+        <p:nvCxnSpPr>
+          <p:cNvPr id="61" name="Straight Connector 60">
+            <a:extLst>
+              <a:ext uri="{FF2B5EF4-FFF2-40B4-BE49-F238E27FC236}">
+                <a16:creationId xmlns:a16="http://schemas.microsoft.com/office/drawing/2014/main" id="{2860A699-A13A-837B-D03B-E7B43018B423}"/>
+              </a:ext>
+            </a:extLst>
+          </p:cNvPr>
+          <p:cNvCxnSpPr>
+            <a:cxnSpLocks/>
+          </p:cNvCxnSpPr>
+          <p:nvPr/>
+        </p:nvCxnSpPr>
+        <p:spPr>
+          <a:xfrm>
+            <a:off x="10864679" y="3881828"/>
+            <a:ext cx="127262" cy="0"/>
+          </a:xfrm>
+          <a:prstGeom prst="line">
+            <a:avLst/>
+          </a:prstGeom>
+          <a:ln>
+            <a:solidFill>
+              <a:srgbClr val="FF0000"/>
+            </a:solidFill>
+          </a:ln>
+        </p:spPr>
+        <p:style>
+          <a:lnRef idx="2">
+            <a:schemeClr val="accent1"/>
+          </a:lnRef>
+          <a:fillRef idx="0">
+            <a:schemeClr val="accent1"/>
+          </a:fillRef>
+          <a:effectRef idx="1">
+            <a:schemeClr val="accent1"/>
+          </a:effectRef>
+          <a:fontRef idx="minor">
+            <a:schemeClr val="tx1"/>
+          </a:fontRef>
+        </p:style>
+      </p:cxnSp>
+      <p:sp>
+        <p:nvSpPr>
+          <p:cNvPr id="263" name="TextBox 262">
+            <a:extLst>
+              <a:ext uri="{FF2B5EF4-FFF2-40B4-BE49-F238E27FC236}">
+                <a16:creationId xmlns:a16="http://schemas.microsoft.com/office/drawing/2014/main" id="{F4E504A4-F7AA-19F4-57FF-4F5247003966}"/>
+              </a:ext>
+            </a:extLst>
+          </p:cNvPr>
+          <p:cNvSpPr txBox="1"/>
+          <p:nvPr/>
+        </p:nvSpPr>
+        <p:spPr>
+          <a:xfrm>
+            <a:off x="10964312" y="3473909"/>
+            <a:ext cx="684803" cy="230832"/>
+          </a:xfrm>
+          <a:prstGeom prst="rect">
+            <a:avLst/>
+          </a:prstGeom>
+          <a:noFill/>
+        </p:spPr>
+        <p:txBody>
+          <a:bodyPr wrap="none" rtlCol="0">
+            <a:spAutoFit/>
+          </a:bodyPr>
+          <a:lstStyle/>
+          <a:p>
+            <a:pPr algn="ctr"/>
+            <a:r>
+              <a:rPr lang="en-US" sz="900" dirty="0" err="1">
+                <a:solidFill>
+                  <a:srgbClr val="FF0000"/>
+                </a:solidFill>
+              </a:rPr>
+              <a:t>load_addr</a:t>
+            </a:r>
+            <a:endParaRPr lang="en-US" sz="900" dirty="0">
+              <a:solidFill>
+                <a:srgbClr val="FF0000"/>
+              </a:solidFill>
+            </a:endParaRPr>
+          </a:p>
+        </p:txBody>
+      </p:sp>
+      <p:sp>
+        <p:nvSpPr>
+          <p:cNvPr id="267" name="TextBox 266">
+            <a:extLst>
+              <a:ext uri="{FF2B5EF4-FFF2-40B4-BE49-F238E27FC236}">
+                <a16:creationId xmlns:a16="http://schemas.microsoft.com/office/drawing/2014/main" id="{DAAA4D50-437E-30DF-1867-5B1E5337431F}"/>
+              </a:ext>
+            </a:extLst>
+          </p:cNvPr>
+          <p:cNvSpPr txBox="1"/>
+          <p:nvPr/>
+        </p:nvSpPr>
+        <p:spPr>
+          <a:xfrm>
+            <a:off x="10969389" y="3623659"/>
+            <a:ext cx="718466" cy="230832"/>
+          </a:xfrm>
+          <a:prstGeom prst="rect">
+            <a:avLst/>
+          </a:prstGeom>
+          <a:noFill/>
+        </p:spPr>
+        <p:txBody>
+          <a:bodyPr wrap="none" rtlCol="0">
+            <a:spAutoFit/>
+          </a:bodyPr>
+          <a:lstStyle/>
+          <a:p>
+            <a:pPr algn="ctr"/>
+            <a:r>
+              <a:rPr lang="en-US" sz="900" dirty="0" err="1">
+                <a:solidFill>
+                  <a:srgbClr val="FF0000"/>
+                </a:solidFill>
+              </a:rPr>
+              <a:t>mem_read</a:t>
+            </a:r>
+            <a:endParaRPr lang="en-US" sz="900" dirty="0">
+              <a:solidFill>
+                <a:srgbClr val="FF0000"/>
+              </a:solidFill>
+            </a:endParaRPr>
+          </a:p>
+        </p:txBody>
+      </p:sp>
+      <p:sp>
+        <p:nvSpPr>
+          <p:cNvPr id="268" name="TextBox 267">
+            <a:extLst>
+              <a:ext uri="{FF2B5EF4-FFF2-40B4-BE49-F238E27FC236}">
+                <a16:creationId xmlns:a16="http://schemas.microsoft.com/office/drawing/2014/main" id="{312B6EFE-B07C-540D-A67C-776CAD109336}"/>
+              </a:ext>
+            </a:extLst>
+          </p:cNvPr>
+          <p:cNvSpPr txBox="1"/>
+          <p:nvPr/>
+        </p:nvSpPr>
+        <p:spPr>
+          <a:xfrm>
+            <a:off x="10969389" y="3777088"/>
+            <a:ext cx="521298" cy="230832"/>
+          </a:xfrm>
+          <a:prstGeom prst="rect">
+            <a:avLst/>
+          </a:prstGeom>
+          <a:noFill/>
+        </p:spPr>
+        <p:txBody>
+          <a:bodyPr wrap="none" rtlCol="0">
+            <a:spAutoFit/>
+          </a:bodyPr>
+          <a:lstStyle/>
+          <a:p>
+            <a:pPr algn="ctr"/>
+            <a:r>
+              <a:rPr lang="en-US" sz="900" dirty="0" err="1">
+                <a:solidFill>
+                  <a:srgbClr val="FF0000"/>
+                </a:solidFill>
+              </a:rPr>
+              <a:t>alu_op</a:t>
+            </a:r>
+            <a:endParaRPr lang="en-US" sz="900" dirty="0">
+              <a:solidFill>
+                <a:srgbClr val="FF0000"/>
+              </a:solidFill>
+            </a:endParaRPr>
+          </a:p>
+        </p:txBody>
+      </p:sp>
+      <p:cxnSp>
+        <p:nvCxnSpPr>
+          <p:cNvPr id="274" name="Straight Connector 273">
+            <a:extLst>
+              <a:ext uri="{FF2B5EF4-FFF2-40B4-BE49-F238E27FC236}">
+                <a16:creationId xmlns:a16="http://schemas.microsoft.com/office/drawing/2014/main" id="{D058F4F9-4CA4-439F-FE9E-13AB2ED93639}"/>
+              </a:ext>
+            </a:extLst>
+          </p:cNvPr>
+          <p:cNvCxnSpPr/>
+          <p:nvPr/>
+        </p:nvCxnSpPr>
+        <p:spPr>
+          <a:xfrm>
+            <a:off x="2572114" y="4659369"/>
+            <a:ext cx="994416" cy="0"/>
+          </a:xfrm>
+          <a:prstGeom prst="line">
+            <a:avLst/>
+          </a:prstGeom>
+          <a:ln>
+            <a:solidFill>
+              <a:srgbClr val="FF0000"/>
+            </a:solidFill>
+          </a:ln>
+        </p:spPr>
+        <p:style>
+          <a:lnRef idx="2">
+            <a:schemeClr val="accent1"/>
+          </a:lnRef>
+          <a:fillRef idx="0">
+            <a:schemeClr val="accent1"/>
+          </a:fillRef>
+          <a:effectRef idx="1">
+            <a:schemeClr val="accent1"/>
+          </a:effectRef>
+          <a:fontRef idx="minor">
+            <a:schemeClr val="tx1"/>
+          </a:fontRef>
+        </p:style>
+      </p:cxnSp>
+      <p:cxnSp>
+        <p:nvCxnSpPr>
+          <p:cNvPr id="277" name="Straight Connector 276">
+            <a:extLst>
+              <a:ext uri="{FF2B5EF4-FFF2-40B4-BE49-F238E27FC236}">
+                <a16:creationId xmlns:a16="http://schemas.microsoft.com/office/drawing/2014/main" id="{1FF3254A-CCCA-30E5-15C6-CD8AA4D93A32}"/>
+              </a:ext>
+            </a:extLst>
+          </p:cNvPr>
+          <p:cNvCxnSpPr>
+            <a:cxnSpLocks/>
+          </p:cNvCxnSpPr>
+          <p:nvPr/>
+        </p:nvCxnSpPr>
+        <p:spPr>
+          <a:xfrm>
+            <a:off x="3572081" y="4490866"/>
+            <a:ext cx="6795" cy="717048"/>
+          </a:xfrm>
+          <a:prstGeom prst="line">
+            <a:avLst/>
+          </a:prstGeom>
+          <a:ln>
+            <a:solidFill>
+              <a:srgbClr val="FF0000"/>
+            </a:solidFill>
+          </a:ln>
+        </p:spPr>
+        <p:style>
+          <a:lnRef idx="2">
+            <a:schemeClr val="accent1"/>
+          </a:lnRef>
+          <a:fillRef idx="0">
+            <a:schemeClr val="accent1"/>
+          </a:fillRef>
+          <a:effectRef idx="1">
+            <a:schemeClr val="accent1"/>
+          </a:effectRef>
+          <a:fontRef idx="minor">
+            <a:schemeClr val="tx1"/>
+          </a:fontRef>
+        </p:style>
+      </p:cxnSp>
+      <p:cxnSp>
+        <p:nvCxnSpPr>
+          <p:cNvPr id="283" name="Straight Arrow Connector 282">
+            <a:extLst>
+              <a:ext uri="{FF2B5EF4-FFF2-40B4-BE49-F238E27FC236}">
+                <a16:creationId xmlns:a16="http://schemas.microsoft.com/office/drawing/2014/main" id="{1E1FDC2A-F165-417E-8990-4EB3BAF621B6}"/>
+              </a:ext>
+            </a:extLst>
+          </p:cNvPr>
+          <p:cNvCxnSpPr>
+            <a:cxnSpLocks/>
+          </p:cNvCxnSpPr>
+          <p:nvPr/>
+        </p:nvCxnSpPr>
+        <p:spPr>
+          <a:xfrm>
+            <a:off x="3566640" y="4507267"/>
+            <a:ext cx="222521" cy="0"/>
+          </a:xfrm>
+          <a:prstGeom prst="straightConnector1">
+            <a:avLst/>
+          </a:prstGeom>
+          <a:ln>
+            <a:solidFill>
+              <a:srgbClr val="FF0000"/>
+            </a:solidFill>
+            <a:tailEnd type="triangle"/>
+          </a:ln>
+        </p:spPr>
+        <p:style>
+          <a:lnRef idx="2">
+            <a:schemeClr val="accent1"/>
+          </a:lnRef>
+          <a:fillRef idx="0">
+            <a:schemeClr val="accent1"/>
+          </a:fillRef>
+          <a:effectRef idx="1">
+            <a:schemeClr val="accent1"/>
+          </a:effectRef>
+          <a:fontRef idx="minor">
+            <a:schemeClr val="tx1"/>
+          </a:fontRef>
+        </p:style>
+      </p:cxnSp>
+      <p:cxnSp>
+        <p:nvCxnSpPr>
+          <p:cNvPr id="284" name="Straight Arrow Connector 283">
+            <a:extLst>
+              <a:ext uri="{FF2B5EF4-FFF2-40B4-BE49-F238E27FC236}">
+                <a16:creationId xmlns:a16="http://schemas.microsoft.com/office/drawing/2014/main" id="{55CB471D-F8EF-0BE5-AE0D-1632A06197E4}"/>
+              </a:ext>
+            </a:extLst>
+          </p:cNvPr>
+          <p:cNvCxnSpPr>
+            <a:cxnSpLocks/>
+          </p:cNvCxnSpPr>
+          <p:nvPr/>
+        </p:nvCxnSpPr>
+        <p:spPr>
+          <a:xfrm>
+            <a:off x="3584232" y="4842066"/>
+            <a:ext cx="222521" cy="0"/>
+          </a:xfrm>
+          <a:prstGeom prst="straightConnector1">
+            <a:avLst/>
+          </a:prstGeom>
+          <a:ln>
+            <a:solidFill>
+              <a:srgbClr val="FF0000"/>
+            </a:solidFill>
+            <a:tailEnd type="triangle"/>
+          </a:ln>
+        </p:spPr>
+        <p:style>
+          <a:lnRef idx="2">
+            <a:schemeClr val="accent1"/>
+          </a:lnRef>
+          <a:fillRef idx="0">
+            <a:schemeClr val="accent1"/>
+          </a:fillRef>
+          <a:effectRef idx="1">
+            <a:schemeClr val="accent1"/>
+          </a:effectRef>
+          <a:fontRef idx="minor">
+            <a:schemeClr val="tx1"/>
+          </a:fontRef>
+        </p:style>
+      </p:cxnSp>
+      <p:cxnSp>
+        <p:nvCxnSpPr>
+          <p:cNvPr id="285" name="Straight Arrow Connector 284">
+            <a:extLst>
+              <a:ext uri="{FF2B5EF4-FFF2-40B4-BE49-F238E27FC236}">
+                <a16:creationId xmlns:a16="http://schemas.microsoft.com/office/drawing/2014/main" id="{41854F56-1643-C225-FCB3-BBF4F26D2090}"/>
+              </a:ext>
+            </a:extLst>
+          </p:cNvPr>
+          <p:cNvCxnSpPr>
+            <a:cxnSpLocks/>
+          </p:cNvCxnSpPr>
+          <p:nvPr/>
+        </p:nvCxnSpPr>
+        <p:spPr>
+          <a:xfrm>
+            <a:off x="3584232" y="4966277"/>
+            <a:ext cx="222521" cy="0"/>
+          </a:xfrm>
+          <a:prstGeom prst="straightConnector1">
+            <a:avLst/>
+          </a:prstGeom>
+          <a:ln>
+            <a:solidFill>
+              <a:srgbClr val="FF0000"/>
+            </a:solidFill>
+            <a:tailEnd type="triangle"/>
+          </a:ln>
+        </p:spPr>
+        <p:style>
+          <a:lnRef idx="2">
+            <a:schemeClr val="accent1"/>
+          </a:lnRef>
+          <a:fillRef idx="0">
+            <a:schemeClr val="accent1"/>
+          </a:fillRef>
+          <a:effectRef idx="1">
+            <a:schemeClr val="accent1"/>
+          </a:effectRef>
+          <a:fontRef idx="minor">
+            <a:schemeClr val="tx1"/>
+          </a:fontRef>
+        </p:style>
+      </p:cxnSp>
+      <p:cxnSp>
+        <p:nvCxnSpPr>
+          <p:cNvPr id="287" name="Straight Arrow Connector 286">
+            <a:extLst>
+              <a:ext uri="{FF2B5EF4-FFF2-40B4-BE49-F238E27FC236}">
+                <a16:creationId xmlns:a16="http://schemas.microsoft.com/office/drawing/2014/main" id="{AE448713-CE0E-E8D2-187C-371C7F6AF1C8}"/>
+              </a:ext>
+            </a:extLst>
+          </p:cNvPr>
+          <p:cNvCxnSpPr>
+            <a:cxnSpLocks/>
+          </p:cNvCxnSpPr>
+          <p:nvPr/>
+        </p:nvCxnSpPr>
+        <p:spPr>
+          <a:xfrm>
+            <a:off x="3584755" y="5093544"/>
+            <a:ext cx="222521" cy="0"/>
+          </a:xfrm>
+          <a:prstGeom prst="straightConnector1">
+            <a:avLst/>
+          </a:prstGeom>
+          <a:ln>
+            <a:solidFill>
+              <a:srgbClr val="FF0000"/>
+            </a:solidFill>
+            <a:tailEnd type="triangle"/>
+          </a:ln>
+        </p:spPr>
+        <p:style>
+          <a:lnRef idx="2">
+            <a:schemeClr val="accent1"/>
+          </a:lnRef>
+          <a:fillRef idx="0">
+            <a:schemeClr val="accent1"/>
+          </a:fillRef>
+          <a:effectRef idx="1">
+            <a:schemeClr val="accent1"/>
+          </a:effectRef>
+          <a:fontRef idx="minor">
+            <a:schemeClr val="tx1"/>
+          </a:fontRef>
+        </p:style>
+      </p:cxnSp>
+      <p:cxnSp>
+        <p:nvCxnSpPr>
+          <p:cNvPr id="75" name="Straight Arrow Connector 74">
+            <a:extLst>
+              <a:ext uri="{FF2B5EF4-FFF2-40B4-BE49-F238E27FC236}">
+                <a16:creationId xmlns:a16="http://schemas.microsoft.com/office/drawing/2014/main" id="{1A8B956F-47F4-AA7D-E619-BFD4EF9BFDF1}"/>
+              </a:ext>
+            </a:extLst>
+          </p:cNvPr>
+          <p:cNvCxnSpPr>
+            <a:cxnSpLocks/>
+          </p:cNvCxnSpPr>
+          <p:nvPr/>
+        </p:nvCxnSpPr>
+        <p:spPr>
+          <a:xfrm>
+            <a:off x="3582642" y="4726650"/>
+            <a:ext cx="224111" cy="0"/>
+          </a:xfrm>
+          <a:prstGeom prst="straightConnector1">
+            <a:avLst/>
+          </a:prstGeom>
+          <a:ln>
+            <a:solidFill>
+              <a:srgbClr val="FF0000"/>
+            </a:solidFill>
+            <a:tailEnd type="triangle"/>
+          </a:ln>
+        </p:spPr>
+        <p:style>
+          <a:lnRef idx="2">
+            <a:schemeClr val="accent1"/>
+          </a:lnRef>
+          <a:fillRef idx="0">
+            <a:schemeClr val="accent1"/>
+          </a:fillRef>
+          <a:effectRef idx="1">
+            <a:schemeClr val="accent1"/>
+          </a:effectRef>
+          <a:fontRef idx="minor">
+            <a:schemeClr val="tx1"/>
+          </a:fontRef>
+        </p:style>
+      </p:cxnSp>
+      <p:cxnSp>
+        <p:nvCxnSpPr>
+          <p:cNvPr id="78" name="Straight Arrow Connector 77">
+            <a:extLst>
+              <a:ext uri="{FF2B5EF4-FFF2-40B4-BE49-F238E27FC236}">
+                <a16:creationId xmlns:a16="http://schemas.microsoft.com/office/drawing/2014/main" id="{EBFBB504-689E-FB09-C465-A6D8903EAB1B}"/>
+              </a:ext>
+            </a:extLst>
+          </p:cNvPr>
+          <p:cNvCxnSpPr>
+            <a:cxnSpLocks/>
+          </p:cNvCxnSpPr>
+          <p:nvPr/>
+        </p:nvCxnSpPr>
+        <p:spPr>
+          <a:xfrm>
+            <a:off x="3582642" y="4611234"/>
+            <a:ext cx="224111" cy="0"/>
+          </a:xfrm>
+          <a:prstGeom prst="straightConnector1">
+            <a:avLst/>
+          </a:prstGeom>
+          <a:ln>
+            <a:solidFill>
+              <a:srgbClr val="FF0000"/>
+            </a:solidFill>
+            <a:tailEnd type="triangle"/>
+          </a:ln>
+        </p:spPr>
+        <p:style>
+          <a:lnRef idx="2">
+            <a:schemeClr val="accent1"/>
+          </a:lnRef>
+          <a:fillRef idx="0">
+            <a:schemeClr val="accent1"/>
+          </a:fillRef>
+          <a:effectRef idx="1">
+            <a:schemeClr val="accent1"/>
+          </a:effectRef>
+          <a:fontRef idx="minor">
+            <a:schemeClr val="tx1"/>
+          </a:fontRef>
+        </p:style>
+      </p:cxnSp>
+      <p:cxnSp>
+        <p:nvCxnSpPr>
+          <p:cNvPr id="79" name="Straight Connector 78">
+            <a:extLst>
+              <a:ext uri="{FF2B5EF4-FFF2-40B4-BE49-F238E27FC236}">
+                <a16:creationId xmlns:a16="http://schemas.microsoft.com/office/drawing/2014/main" id="{4C16C293-FC92-71FA-1C3D-476956B85EF4}"/>
+              </a:ext>
+            </a:extLst>
+          </p:cNvPr>
+          <p:cNvCxnSpPr>
+            <a:cxnSpLocks/>
+          </p:cNvCxnSpPr>
+          <p:nvPr/>
+        </p:nvCxnSpPr>
+        <p:spPr>
+          <a:xfrm flipH="1">
+            <a:off x="2954806" y="4584374"/>
+            <a:ext cx="190540" cy="162553"/>
+          </a:xfrm>
+          <a:prstGeom prst="line">
+            <a:avLst/>
+          </a:prstGeom>
+          <a:ln>
+            <a:solidFill>
+              <a:srgbClr val="FF0000"/>
+            </a:solidFill>
+          </a:ln>
+        </p:spPr>
+        <p:style>
+          <a:lnRef idx="2">
+            <a:schemeClr val="accent1"/>
+          </a:lnRef>
+          <a:fillRef idx="0">
+            <a:schemeClr val="accent1"/>
+          </a:fillRef>
+          <a:effectRef idx="1">
+            <a:schemeClr val="accent1"/>
+          </a:effectRef>
+          <a:fontRef idx="minor">
+            <a:schemeClr val="tx1"/>
+          </a:fontRef>
+        </p:style>
+      </p:cxnSp>
+      <p:sp>
+        <p:nvSpPr>
+          <p:cNvPr id="86" name="TextBox 85">
+            <a:extLst>
+              <a:ext uri="{FF2B5EF4-FFF2-40B4-BE49-F238E27FC236}">
+                <a16:creationId xmlns:a16="http://schemas.microsoft.com/office/drawing/2014/main" id="{61E34F98-8014-D00F-25E8-12F4ED0405BA}"/>
+              </a:ext>
+            </a:extLst>
+          </p:cNvPr>
+          <p:cNvSpPr txBox="1"/>
+          <p:nvPr/>
+        </p:nvSpPr>
+        <p:spPr>
+          <a:xfrm>
+            <a:off x="2928699" y="4389395"/>
+            <a:ext cx="245580" cy="230832"/>
+          </a:xfrm>
+          <a:prstGeom prst="rect">
+            <a:avLst/>
+          </a:prstGeom>
+          <a:noFill/>
+        </p:spPr>
+        <p:txBody>
+          <a:bodyPr wrap="none" rtlCol="0">
+            <a:spAutoFit/>
+          </a:bodyPr>
+          <a:lstStyle/>
+          <a:p>
+            <a:pPr algn="ctr"/>
+            <a:r>
+              <a:rPr lang="en-US" sz="900" dirty="0">
+                <a:solidFill>
+                  <a:srgbClr val="FF0000"/>
+                </a:solidFill>
+              </a:rPr>
+              <a:t>7</a:t>
+            </a:r>
+          </a:p>
+        </p:txBody>
+      </p:sp>
+      <p:sp>
+        <p:nvSpPr>
+          <p:cNvPr id="92" name="TextBox 91">
+            <a:extLst>
+              <a:ext uri="{FF2B5EF4-FFF2-40B4-BE49-F238E27FC236}">
+                <a16:creationId xmlns:a16="http://schemas.microsoft.com/office/drawing/2014/main" id="{0DF62D31-992B-9692-0637-EEB11D05A2E2}"/>
+              </a:ext>
+            </a:extLst>
+          </p:cNvPr>
+          <p:cNvSpPr txBox="1"/>
+          <p:nvPr/>
+        </p:nvSpPr>
+        <p:spPr>
+          <a:xfrm>
+            <a:off x="10950153" y="48420"/>
+            <a:ext cx="1132041" cy="369332"/>
+          </a:xfrm>
+          <a:prstGeom prst="rect">
+            <a:avLst/>
+          </a:prstGeom>
+          <a:noFill/>
+        </p:spPr>
+        <p:txBody>
+          <a:bodyPr wrap="none" rtlCol="0">
+            <a:spAutoFit/>
+          </a:bodyPr>
+          <a:lstStyle/>
+          <a:p>
+            <a:pPr algn="ctr"/>
+            <a:r>
+              <a:rPr lang="en-US" b="1" dirty="0">
+                <a:solidFill>
+                  <a:srgbClr val="FF0000"/>
+                </a:solidFill>
+              </a:rPr>
+              <a:t>C1C Sick</a:t>
+            </a:r>
+          </a:p>
+        </p:txBody>
+      </p:sp>
+      <p:cxnSp>
+        <p:nvCxnSpPr>
+          <p:cNvPr id="2" name="Straight Connector 1">
+            <a:extLst>
+              <a:ext uri="{FF2B5EF4-FFF2-40B4-BE49-F238E27FC236}">
+                <a16:creationId xmlns:a16="http://schemas.microsoft.com/office/drawing/2014/main" id="{6DD2082F-27DA-2BF9-22A0-E9CCCCFB4014}"/>
+              </a:ext>
+            </a:extLst>
+          </p:cNvPr>
+          <p:cNvCxnSpPr>
+            <a:cxnSpLocks/>
+          </p:cNvCxnSpPr>
+          <p:nvPr/>
+        </p:nvCxnSpPr>
+        <p:spPr>
+          <a:xfrm>
+            <a:off x="9506818" y="3799780"/>
+            <a:ext cx="127262" cy="0"/>
+          </a:xfrm>
+          <a:prstGeom prst="line">
+            <a:avLst/>
+          </a:prstGeom>
+          <a:ln>
+            <a:solidFill>
+              <a:srgbClr val="FF0000"/>
+            </a:solidFill>
+          </a:ln>
+        </p:spPr>
+        <p:style>
+          <a:lnRef idx="2">
+            <a:schemeClr val="accent1"/>
+          </a:lnRef>
+          <a:fillRef idx="0">
+            <a:schemeClr val="accent1"/>
+          </a:fillRef>
+          <a:effectRef idx="1">
+            <a:schemeClr val="accent1"/>
+          </a:effectRef>
+          <a:fontRef idx="minor">
+            <a:schemeClr val="tx1"/>
+          </a:fontRef>
+        </p:style>
+      </p:cxnSp>
+      <p:cxnSp>
+        <p:nvCxnSpPr>
+          <p:cNvPr id="18" name="Straight Connector 17">
+            <a:extLst>
+              <a:ext uri="{FF2B5EF4-FFF2-40B4-BE49-F238E27FC236}">
+                <a16:creationId xmlns:a16="http://schemas.microsoft.com/office/drawing/2014/main" id="{B7486644-A515-0D8F-B21F-83AC84FFFC4A}"/>
+              </a:ext>
+            </a:extLst>
+          </p:cNvPr>
+          <p:cNvCxnSpPr>
+            <a:cxnSpLocks/>
+          </p:cNvCxnSpPr>
+          <p:nvPr/>
+        </p:nvCxnSpPr>
+        <p:spPr>
+          <a:xfrm>
+            <a:off x="9506818" y="3931058"/>
+            <a:ext cx="127262" cy="0"/>
+          </a:xfrm>
+          <a:prstGeom prst="line">
+            <a:avLst/>
+          </a:prstGeom>
+          <a:ln>
+            <a:solidFill>
+              <a:srgbClr val="FF0000"/>
+            </a:solidFill>
+          </a:ln>
+        </p:spPr>
+        <p:style>
+          <a:lnRef idx="2">
+            <a:schemeClr val="accent1"/>
+          </a:lnRef>
+          <a:fillRef idx="0">
+            <a:schemeClr val="accent1"/>
+          </a:fillRef>
+          <a:effectRef idx="1">
+            <a:schemeClr val="accent1"/>
+          </a:effectRef>
+          <a:fontRef idx="minor">
+            <a:schemeClr val="tx1"/>
+          </a:fontRef>
+        </p:style>
+      </p:cxnSp>
+      <p:cxnSp>
+        <p:nvCxnSpPr>
+          <p:cNvPr id="20" name="Straight Connector 19">
+            <a:extLst>
+              <a:ext uri="{FF2B5EF4-FFF2-40B4-BE49-F238E27FC236}">
+                <a16:creationId xmlns:a16="http://schemas.microsoft.com/office/drawing/2014/main" id="{7F36F50A-FB00-E855-C1B8-1D98A0F13275}"/>
+              </a:ext>
+            </a:extLst>
+          </p:cNvPr>
+          <p:cNvCxnSpPr>
+            <a:cxnSpLocks/>
+          </p:cNvCxnSpPr>
+          <p:nvPr/>
+        </p:nvCxnSpPr>
+        <p:spPr>
+          <a:xfrm>
+            <a:off x="9506818" y="4047113"/>
+            <a:ext cx="127262" cy="0"/>
+          </a:xfrm>
+          <a:prstGeom prst="line">
+            <a:avLst/>
+          </a:prstGeom>
+          <a:ln>
+            <a:solidFill>
+              <a:srgbClr val="FF0000"/>
+            </a:solidFill>
+          </a:ln>
+        </p:spPr>
+        <p:style>
+          <a:lnRef idx="2">
+            <a:schemeClr val="accent1"/>
+          </a:lnRef>
+          <a:fillRef idx="0">
+            <a:schemeClr val="accent1"/>
+          </a:fillRef>
+          <a:effectRef idx="1">
+            <a:schemeClr val="accent1"/>
+          </a:effectRef>
+          <a:fontRef idx="minor">
+            <a:schemeClr val="tx1"/>
+          </a:fontRef>
+        </p:style>
+      </p:cxnSp>
+      <p:sp>
+        <p:nvSpPr>
+          <p:cNvPr id="21" name="TextBox 20">
+            <a:extLst>
+              <a:ext uri="{FF2B5EF4-FFF2-40B4-BE49-F238E27FC236}">
+                <a16:creationId xmlns:a16="http://schemas.microsoft.com/office/drawing/2014/main" id="{D918C6FA-A3BD-FDE2-19B4-40A0C268AF14}"/>
+              </a:ext>
+            </a:extLst>
+          </p:cNvPr>
+          <p:cNvSpPr txBox="1"/>
+          <p:nvPr/>
+        </p:nvSpPr>
+        <p:spPr>
+          <a:xfrm>
+            <a:off x="9594617" y="3816281"/>
+            <a:ext cx="537328" cy="230832"/>
+          </a:xfrm>
+          <a:prstGeom prst="rect">
+            <a:avLst/>
+          </a:prstGeom>
+          <a:noFill/>
+        </p:spPr>
+        <p:txBody>
+          <a:bodyPr wrap="none" rtlCol="0">
+            <a:spAutoFit/>
+          </a:bodyPr>
+          <a:lstStyle/>
+          <a:p>
+            <a:pPr algn="ctr"/>
+            <a:r>
+              <a:rPr lang="en-US" sz="900" dirty="0">
+                <a:solidFill>
+                  <a:srgbClr val="FF0000"/>
+                </a:solidFill>
+              </a:rPr>
+              <a:t>branch</a:t>
+            </a:r>
+          </a:p>
+        </p:txBody>
+      </p:sp>
+      <p:sp>
+        <p:nvSpPr>
+          <p:cNvPr id="23" name="TextBox 22">
+            <a:extLst>
+              <a:ext uri="{FF2B5EF4-FFF2-40B4-BE49-F238E27FC236}">
+                <a16:creationId xmlns:a16="http://schemas.microsoft.com/office/drawing/2014/main" id="{73220E8B-F4A3-1D35-95C3-6277215120F7}"/>
+              </a:ext>
+            </a:extLst>
+          </p:cNvPr>
+          <p:cNvSpPr txBox="1"/>
+          <p:nvPr/>
+        </p:nvSpPr>
+        <p:spPr>
+          <a:xfrm>
+            <a:off x="9594617" y="3945511"/>
+            <a:ext cx="437941" cy="230832"/>
+          </a:xfrm>
+          <a:prstGeom prst="rect">
+            <a:avLst/>
+          </a:prstGeom>
+          <a:noFill/>
+        </p:spPr>
+        <p:txBody>
+          <a:bodyPr wrap="none" rtlCol="0">
+            <a:spAutoFit/>
+          </a:bodyPr>
+          <a:lstStyle/>
+          <a:p>
+            <a:pPr algn="ctr"/>
+            <a:r>
+              <a:rPr lang="en-US" sz="900" dirty="0">
+                <a:solidFill>
+                  <a:srgbClr val="FF0000"/>
+                </a:solidFill>
+              </a:rPr>
+              <a:t>jump</a:t>
+            </a:r>
+          </a:p>
+        </p:txBody>
+      </p:sp>
+      <p:cxnSp>
+        <p:nvCxnSpPr>
+          <p:cNvPr id="233" name="Straight Connector 232">
+            <a:extLst>
+              <a:ext uri="{FF2B5EF4-FFF2-40B4-BE49-F238E27FC236}">
+                <a16:creationId xmlns:a16="http://schemas.microsoft.com/office/drawing/2014/main" id="{E45BEB58-BD78-EFA7-0BA4-B2FC8C8AE64F}"/>
+              </a:ext>
+            </a:extLst>
+          </p:cNvPr>
+          <p:cNvCxnSpPr>
+            <a:cxnSpLocks/>
+          </p:cNvCxnSpPr>
+          <p:nvPr/>
+        </p:nvCxnSpPr>
+        <p:spPr>
+          <a:xfrm>
+            <a:off x="10848722" y="4047113"/>
+            <a:ext cx="152660" cy="0"/>
+          </a:xfrm>
+          <a:prstGeom prst="line">
+            <a:avLst/>
+          </a:prstGeom>
+          <a:ln>
+            <a:solidFill>
+              <a:srgbClr val="FF0000"/>
+            </a:solidFill>
+          </a:ln>
+        </p:spPr>
+        <p:style>
+          <a:lnRef idx="2">
+            <a:schemeClr val="accent1"/>
+          </a:lnRef>
+          <a:fillRef idx="0">
+            <a:schemeClr val="accent1"/>
+          </a:fillRef>
+          <a:effectRef idx="1">
+            <a:schemeClr val="accent1"/>
+          </a:effectRef>
+          <a:fontRef idx="minor">
+            <a:schemeClr val="tx1"/>
+          </a:fontRef>
+        </p:style>
+      </p:cxnSp>
+      <p:sp>
+        <p:nvSpPr>
+          <p:cNvPr id="241" name="TextBox 240">
+            <a:extLst>
+              <a:ext uri="{FF2B5EF4-FFF2-40B4-BE49-F238E27FC236}">
+                <a16:creationId xmlns:a16="http://schemas.microsoft.com/office/drawing/2014/main" id="{B955AF51-5CE5-2FF8-9426-3B35D47A84DB}"/>
+              </a:ext>
+            </a:extLst>
+          </p:cNvPr>
+          <p:cNvSpPr txBox="1"/>
+          <p:nvPr/>
+        </p:nvSpPr>
+        <p:spPr>
+          <a:xfrm>
+            <a:off x="10969389" y="3922995"/>
+            <a:ext cx="436338" cy="230832"/>
+          </a:xfrm>
+          <a:prstGeom prst="rect">
+            <a:avLst/>
+          </a:prstGeom>
+          <a:noFill/>
+        </p:spPr>
+        <p:txBody>
+          <a:bodyPr wrap="none" rtlCol="0">
+            <a:spAutoFit/>
+          </a:bodyPr>
+          <a:lstStyle/>
+          <a:p>
+            <a:pPr algn="ctr"/>
+            <a:r>
+              <a:rPr lang="en-US" sz="900" dirty="0">
+                <a:solidFill>
+                  <a:srgbClr val="FF0000"/>
+                </a:solidFill>
+              </a:rPr>
+              <a:t>state</a:t>
             </a:r>
           </a:p>
         </p:txBody>
@@ -10585,4 +12855,319 @@
     </a:ext>
   </a:extLst>
 </a:theme>
+</file>
+
+<file path=ppt/theme/theme2.xml><?xml version="1.0" encoding="utf-8"?>
+<a:theme xmlns:a="http://schemas.openxmlformats.org/drawingml/2006/main" name="Office Theme">
+  <a:themeElements>
+    <a:clrScheme name="Office">
+      <a:dk1>
+        <a:sysClr val="windowText" lastClr="000000"/>
+      </a:dk1>
+      <a:lt1>
+        <a:sysClr val="window" lastClr="FFFFFF"/>
+      </a:lt1>
+      <a:dk2>
+        <a:srgbClr val="0E2841"/>
+      </a:dk2>
+      <a:lt2>
+        <a:srgbClr val="E8E8E8"/>
+      </a:lt2>
+      <a:accent1>
+        <a:srgbClr val="156082"/>
+      </a:accent1>
+      <a:accent2>
+        <a:srgbClr val="E97132"/>
+      </a:accent2>
+      <a:accent3>
+        <a:srgbClr val="196B24"/>
+      </a:accent3>
+      <a:accent4>
+        <a:srgbClr val="0F9ED5"/>
+      </a:accent4>
+      <a:accent5>
+        <a:srgbClr val="A02B93"/>
+      </a:accent5>
+      <a:accent6>
+        <a:srgbClr val="4EA72E"/>
+      </a:accent6>
+      <a:hlink>
+        <a:srgbClr val="467886"/>
+      </a:hlink>
+      <a:folHlink>
+        <a:srgbClr val="96607D"/>
+      </a:folHlink>
+    </a:clrScheme>
+    <a:fontScheme name="Office">
+      <a:majorFont>
+        <a:latin typeface="Aptos Display" panose="02110004020202020204"/>
+        <a:ea typeface=""/>
+        <a:cs typeface=""/>
+        <a:font script="Jpan" typeface="游ゴシック Light"/>
+        <a:font script="Hang" typeface="맑은 고딕"/>
+        <a:font script="Hans" typeface="等线 Light"/>
+        <a:font script="Hant" typeface="新細明體"/>
+        <a:font script="Arab" typeface="Times New Roman"/>
+        <a:font script="Hebr" typeface="Times New Roman"/>
+        <a:font script="Thai" typeface="Angsana New"/>
+        <a:font script="Ethi" typeface="Nyala"/>
+        <a:font script="Beng" typeface="Vrinda"/>
+        <a:font script="Gujr" typeface="Shruti"/>
+        <a:font script="Khmr" typeface="MoolBoran"/>
+        <a:font script="Knda" typeface="Tunga"/>
+        <a:font script="Guru" typeface="Raavi"/>
+        <a:font script="Cans" typeface="Euphemia"/>
+        <a:font script="Cher" typeface="Plantagenet Cherokee"/>
+        <a:font script="Yiii" typeface="Microsoft Yi Baiti"/>
+        <a:font script="Tibt" typeface="Microsoft Himalaya"/>
+        <a:font script="Thaa" typeface="MV Boli"/>
+        <a:font script="Deva" typeface="Mangal"/>
+        <a:font script="Telu" typeface="Gautami"/>
+        <a:font script="Taml" typeface="Latha"/>
+        <a:font script="Syrc" typeface="Estrangelo Edessa"/>
+        <a:font script="Orya" typeface="Kalinga"/>
+        <a:font script="Mlym" typeface="Kartika"/>
+        <a:font script="Laoo" typeface="DokChampa"/>
+        <a:font script="Sinh" typeface="Iskoola Pota"/>
+        <a:font script="Mong" typeface="Mongolian Baiti"/>
+        <a:font script="Viet" typeface="Times New Roman"/>
+        <a:font script="Uigh" typeface="Microsoft Uighur"/>
+        <a:font script="Geor" typeface="Sylfaen"/>
+        <a:font script="Armn" typeface="Arial"/>
+        <a:font script="Bugi" typeface="Leelawadee UI"/>
+        <a:font script="Bopo" typeface="Microsoft JhengHei"/>
+        <a:font script="Java" typeface="Javanese Text"/>
+        <a:font script="Lisu" typeface="Segoe UI"/>
+        <a:font script="Mymr" typeface="Myanmar Text"/>
+        <a:font script="Nkoo" typeface="Ebrima"/>
+        <a:font script="Olck" typeface="Nirmala UI"/>
+        <a:font script="Osma" typeface="Ebrima"/>
+        <a:font script="Phag" typeface="Phagspa"/>
+        <a:font script="Syrn" typeface="Estrangelo Edessa"/>
+        <a:font script="Syrj" typeface="Estrangelo Edessa"/>
+        <a:font script="Syre" typeface="Estrangelo Edessa"/>
+        <a:font script="Sora" typeface="Nirmala UI"/>
+        <a:font script="Tale" typeface="Microsoft Tai Le"/>
+        <a:font script="Talu" typeface="Microsoft New Tai Lue"/>
+        <a:font script="Tfng" typeface="Ebrima"/>
+      </a:majorFont>
+      <a:minorFont>
+        <a:latin typeface="Aptos" panose="02110004020202020204"/>
+        <a:ea typeface=""/>
+        <a:cs typeface=""/>
+        <a:font script="Jpan" typeface="游ゴシック"/>
+        <a:font script="Hang" typeface="맑은 고딕"/>
+        <a:font script="Hans" typeface="等线"/>
+        <a:font script="Hant" typeface="新細明體"/>
+        <a:font script="Arab" typeface="Arial"/>
+        <a:font script="Hebr" typeface="Arial"/>
+        <a:font script="Thai" typeface="Cordia New"/>
+        <a:font script="Ethi" typeface="Nyala"/>
+        <a:font script="Beng" typeface="Vrinda"/>
+        <a:font script="Gujr" typeface="Shruti"/>
+        <a:font script="Khmr" typeface="DaunPenh"/>
+        <a:font script="Knda" typeface="Tunga"/>
+        <a:font script="Guru" typeface="Raavi"/>
+        <a:font script="Cans" typeface="Euphemia"/>
+        <a:font script="Cher" typeface="Plantagenet Cherokee"/>
+        <a:font script="Yiii" typeface="Microsoft Yi Baiti"/>
+        <a:font script="Tibt" typeface="Microsoft Himalaya"/>
+        <a:font script="Thaa" typeface="MV Boli"/>
+        <a:font script="Deva" typeface="Mangal"/>
+        <a:font script="Telu" typeface="Gautami"/>
+        <a:font script="Taml" typeface="Latha"/>
+        <a:font script="Syrc" typeface="Estrangelo Edessa"/>
+        <a:font script="Orya" typeface="Kalinga"/>
+        <a:font script="Mlym" typeface="Kartika"/>
+        <a:font script="Laoo" typeface="DokChampa"/>
+        <a:font script="Sinh" typeface="Iskoola Pota"/>
+        <a:font script="Mong" typeface="Mongolian Baiti"/>
+        <a:font script="Viet" typeface="Arial"/>
+        <a:font script="Uigh" typeface="Microsoft Uighur"/>
+        <a:font script="Geor" typeface="Sylfaen"/>
+        <a:font script="Armn" typeface="Arial"/>
+        <a:font script="Bugi" typeface="Leelawadee UI"/>
+        <a:font script="Bopo" typeface="Microsoft JhengHei"/>
+        <a:font script="Java" typeface="Javanese Text"/>
+        <a:font script="Lisu" typeface="Segoe UI"/>
+        <a:font script="Mymr" typeface="Myanmar Text"/>
+        <a:font script="Nkoo" typeface="Ebrima"/>
+        <a:font script="Olck" typeface="Nirmala UI"/>
+        <a:font script="Osma" typeface="Ebrima"/>
+        <a:font script="Phag" typeface="Phagspa"/>
+        <a:font script="Syrn" typeface="Estrangelo Edessa"/>
+        <a:font script="Syrj" typeface="Estrangelo Edessa"/>
+        <a:font script="Syre" typeface="Estrangelo Edessa"/>
+        <a:font script="Sora" typeface="Nirmala UI"/>
+        <a:font script="Tale" typeface="Microsoft Tai Le"/>
+        <a:font script="Talu" typeface="Microsoft New Tai Lue"/>
+        <a:font script="Tfng" typeface="Ebrima"/>
+      </a:minorFont>
+    </a:fontScheme>
+    <a:fmtScheme name="Office">
+      <a:fillStyleLst>
+        <a:solidFill>
+          <a:schemeClr val="phClr"/>
+        </a:solidFill>
+        <a:gradFill rotWithShape="1">
+          <a:gsLst>
+            <a:gs pos="0">
+              <a:schemeClr val="phClr">
+                <a:lumMod val="110000"/>
+                <a:satMod val="105000"/>
+                <a:tint val="67000"/>
+              </a:schemeClr>
+            </a:gs>
+            <a:gs pos="50000">
+              <a:schemeClr val="phClr">
+                <a:lumMod val="105000"/>
+                <a:satMod val="103000"/>
+                <a:tint val="73000"/>
+              </a:schemeClr>
+            </a:gs>
+            <a:gs pos="100000">
+              <a:schemeClr val="phClr">
+                <a:lumMod val="105000"/>
+                <a:satMod val="109000"/>
+                <a:tint val="81000"/>
+              </a:schemeClr>
+            </a:gs>
+          </a:gsLst>
+          <a:lin ang="5400000" scaled="0"/>
+        </a:gradFill>
+        <a:gradFill rotWithShape="1">
+          <a:gsLst>
+            <a:gs pos="0">
+              <a:schemeClr val="phClr">
+                <a:satMod val="103000"/>
+                <a:lumMod val="102000"/>
+                <a:tint val="94000"/>
+              </a:schemeClr>
+            </a:gs>
+            <a:gs pos="50000">
+              <a:schemeClr val="phClr">
+                <a:satMod val="110000"/>
+                <a:lumMod val="100000"/>
+                <a:shade val="100000"/>
+              </a:schemeClr>
+            </a:gs>
+            <a:gs pos="100000">
+              <a:schemeClr val="phClr">
+                <a:lumMod val="99000"/>
+                <a:satMod val="120000"/>
+                <a:shade val="78000"/>
+              </a:schemeClr>
+            </a:gs>
+          </a:gsLst>
+          <a:lin ang="5400000" scaled="0"/>
+        </a:gradFill>
+      </a:fillStyleLst>
+      <a:lnStyleLst>
+        <a:ln w="12700" cap="flat" cmpd="sng" algn="ctr">
+          <a:solidFill>
+            <a:schemeClr val="phClr"/>
+          </a:solidFill>
+          <a:prstDash val="solid"/>
+          <a:miter lim="800000"/>
+        </a:ln>
+        <a:ln w="19050" cap="flat" cmpd="sng" algn="ctr">
+          <a:solidFill>
+            <a:schemeClr val="phClr"/>
+          </a:solidFill>
+          <a:prstDash val="solid"/>
+          <a:miter lim="800000"/>
+        </a:ln>
+        <a:ln w="25400" cap="flat" cmpd="sng" algn="ctr">
+          <a:solidFill>
+            <a:schemeClr val="phClr"/>
+          </a:solidFill>
+          <a:prstDash val="solid"/>
+          <a:miter lim="800000"/>
+        </a:ln>
+      </a:lnStyleLst>
+      <a:effectStyleLst>
+        <a:effectStyle>
+          <a:effectLst/>
+        </a:effectStyle>
+        <a:effectStyle>
+          <a:effectLst/>
+        </a:effectStyle>
+        <a:effectStyle>
+          <a:effectLst>
+            <a:outerShdw blurRad="57150" dist="19050" dir="5400000" algn="ctr" rotWithShape="0">
+              <a:srgbClr val="000000">
+                <a:alpha val="63000"/>
+              </a:srgbClr>
+            </a:outerShdw>
+          </a:effectLst>
+        </a:effectStyle>
+      </a:effectStyleLst>
+      <a:bgFillStyleLst>
+        <a:solidFill>
+          <a:schemeClr val="phClr"/>
+        </a:solidFill>
+        <a:solidFill>
+          <a:schemeClr val="phClr">
+            <a:tint val="95000"/>
+            <a:satMod val="170000"/>
+          </a:schemeClr>
+        </a:solidFill>
+        <a:gradFill rotWithShape="1">
+          <a:gsLst>
+            <a:gs pos="0">
+              <a:schemeClr val="phClr">
+                <a:tint val="93000"/>
+                <a:satMod val="150000"/>
+                <a:shade val="98000"/>
+                <a:lumMod val="102000"/>
+              </a:schemeClr>
+            </a:gs>
+            <a:gs pos="50000">
+              <a:schemeClr val="phClr">
+                <a:tint val="98000"/>
+                <a:satMod val="130000"/>
+                <a:shade val="90000"/>
+                <a:lumMod val="103000"/>
+              </a:schemeClr>
+            </a:gs>
+            <a:gs pos="100000">
+              <a:schemeClr val="phClr">
+                <a:shade val="63000"/>
+                <a:satMod val="120000"/>
+              </a:schemeClr>
+            </a:gs>
+          </a:gsLst>
+          <a:lin ang="5400000" scaled="0"/>
+        </a:gradFill>
+      </a:bgFillStyleLst>
+    </a:fmtScheme>
+  </a:themeElements>
+  <a:objectDefaults>
+    <a:lnDef>
+      <a:spPr/>
+      <a:bodyPr/>
+      <a:lstStyle/>
+      <a:style>
+        <a:lnRef idx="2">
+          <a:schemeClr val="accent1"/>
+        </a:lnRef>
+        <a:fillRef idx="0">
+          <a:schemeClr val="accent1"/>
+        </a:fillRef>
+        <a:effectRef idx="1">
+          <a:schemeClr val="accent1"/>
+        </a:effectRef>
+        <a:fontRef idx="minor">
+          <a:schemeClr val="tx1"/>
+        </a:fontRef>
+      </a:style>
+    </a:lnDef>
+  </a:objectDefaults>
+  <a:extraClrSchemeLst/>
+  <a:extLst>
+    <a:ext uri="{05A4C25C-085E-4340-85A3-A5531E510DB2}">
+      <thm15:themeFamily xmlns:thm15="http://schemas.microsoft.com/office/thememl/2012/main" name="Office Theme" id="{2E142A2C-CD16-42D6-873A-C26D2A0506FA}" vid="{1BDDFF52-6CD6-40A5-AB3C-68EB2F1E4D0A}"/>
+    </a:ext>
+  </a:extLst>
+</a:theme>
 </file>
</xml_diff>